<commit_message>
Update DM/SHAP/Granger slides and figures, add fixed-selection DM run
Filter Granger p-value labels to significant bars + lego CH1, regenerate
shap/model-comparison/DM slides, and add a fixed-selection DM test script
with its results.

Co-Authored-By: Claude Sonnet 4.6 <noreply@anthropic.com>
</commit_message>
<xml_diff>
--- a/slide_granger_by_asset_v3.pptx
+++ b/slide_granger_by_asset_v3.pptx
@@ -5,9 +5,9 @@
     <p:sldMasterId id="2147483648" r:id="rId1"/>
   </p:sldMasterIdLst>
   <p:sldIdLst>
-    <p:sldId id="256" r:id="rId2"/>
+    <p:sldId id="256" r:id="rId7"/>
   </p:sldIdLst>
-  <p:sldSz cx="12188825" cy="6858000"/>
+  <p:sldSz cx="12188952" cy="6858000" type="screen4x3"/>
   <p:notesSz cx="6858000" cy="9144000"/>
   <p:defaultTextStyle>
     <a:defPPr>
@@ -104,22 +104,6 @@
       </a:defRPr>
     </a:lvl9pPr>
   </p:defaultTextStyle>
-  <p:extLst>
-    <p:ext uri="{EFAFB233-063F-42B5-8137-9DF3F51BA10A}">
-      <p15:sldGuideLst xmlns:p15="http://schemas.microsoft.com/office/powerpoint/2012/main">
-        <p15:guide id="1" orient="horz" pos="2160">
-          <p15:clr>
-            <a:srgbClr val="A4A3A4"/>
-          </p15:clr>
-        </p15:guide>
-        <p15:guide id="2" pos="2880">
-          <p15:clr>
-            <a:srgbClr val="A4A3A4"/>
-          </p15:clr>
-        </p15:guide>
-      </p15:sldGuideLst>
-    </p:ext>
-  </p:extLst>
 </p:presentation>
 </file>
 
@@ -161,9 +145,10 @@
           <a:lstStyle/>
           <a:p>
             <a:r>
-              <a:rPr lang="en-US"/>
+              <a:rPr lang="en-US" smtClean="0"/>
               <a:t>Click to edit Master title style</a:t>
             </a:r>
+            <a:endParaRPr lang="en-US"/>
           </a:p>
         </p:txBody>
       </p:sp>
@@ -279,9 +264,10 @@
           </a:lstStyle>
           <a:p>
             <a:r>
-              <a:rPr lang="en-US"/>
+              <a:rPr lang="en-US" smtClean="0"/>
               <a:t>Click to edit Master subtitle style</a:t>
             </a:r>
+            <a:endParaRPr lang="en-US"/>
           </a:p>
         </p:txBody>
       </p:sp>
@@ -302,7 +288,7 @@
           <a:p>
             <a:fld id="{5BCAD085-E8A6-8845-BD4E-CB4CCA059FC4}" type="datetimeFigureOut">
               <a:rPr lang="en-US" smtClean="0"/>
-              <a:t>6/15/2026</a:t>
+              <a:t>1/27/13</a:t>
             </a:fld>
             <a:endParaRPr lang="en-US"/>
           </a:p>
@@ -396,9 +382,10 @@
           <a:lstStyle/>
           <a:p>
             <a:r>
-              <a:rPr lang="en-US"/>
+              <a:rPr lang="en-US" smtClean="0"/>
               <a:t>Click to edit Master title style</a:t>
             </a:r>
+            <a:endParaRPr lang="en-US"/>
           </a:p>
         </p:txBody>
       </p:sp>
@@ -419,37 +406,38 @@
           <a:p>
             <a:pPr lvl="0"/>
             <a:r>
-              <a:rPr lang="en-US"/>
+              <a:rPr lang="en-US" smtClean="0"/>
               <a:t>Click to edit Master text styles</a:t>
             </a:r>
           </a:p>
           <a:p>
             <a:pPr lvl="1"/>
             <a:r>
-              <a:rPr lang="en-US"/>
+              <a:rPr lang="en-US" smtClean="0"/>
               <a:t>Second level</a:t>
             </a:r>
           </a:p>
           <a:p>
             <a:pPr lvl="2"/>
             <a:r>
-              <a:rPr lang="en-US"/>
+              <a:rPr lang="en-US" smtClean="0"/>
               <a:t>Third level</a:t>
             </a:r>
           </a:p>
           <a:p>
             <a:pPr lvl="3"/>
             <a:r>
-              <a:rPr lang="en-US"/>
+              <a:rPr lang="en-US" smtClean="0"/>
               <a:t>Fourth level</a:t>
             </a:r>
           </a:p>
           <a:p>
             <a:pPr lvl="4"/>
             <a:r>
-              <a:rPr lang="en-US"/>
+              <a:rPr lang="en-US" smtClean="0"/>
               <a:t>Fifth level</a:t>
             </a:r>
+            <a:endParaRPr lang="en-US"/>
           </a:p>
         </p:txBody>
       </p:sp>
@@ -470,7 +458,7 @@
           <a:p>
             <a:fld id="{5BCAD085-E8A6-8845-BD4E-CB4CCA059FC4}" type="datetimeFigureOut">
               <a:rPr lang="en-US" smtClean="0"/>
-              <a:t>6/15/2026</a:t>
+              <a:t>1/27/13</a:t>
             </a:fld>
             <a:endParaRPr lang="en-US"/>
           </a:p>
@@ -569,9 +557,10 @@
           <a:lstStyle/>
           <a:p>
             <a:r>
-              <a:rPr lang="en-US"/>
+              <a:rPr lang="en-US" smtClean="0"/>
               <a:t>Click to edit Master title style</a:t>
             </a:r>
+            <a:endParaRPr lang="en-US"/>
           </a:p>
         </p:txBody>
       </p:sp>
@@ -597,37 +586,38 @@
           <a:p>
             <a:pPr lvl="0"/>
             <a:r>
-              <a:rPr lang="en-US"/>
+              <a:rPr lang="en-US" smtClean="0"/>
               <a:t>Click to edit Master text styles</a:t>
             </a:r>
           </a:p>
           <a:p>
             <a:pPr lvl="1"/>
             <a:r>
-              <a:rPr lang="en-US"/>
+              <a:rPr lang="en-US" smtClean="0"/>
               <a:t>Second level</a:t>
             </a:r>
           </a:p>
           <a:p>
             <a:pPr lvl="2"/>
             <a:r>
-              <a:rPr lang="en-US"/>
+              <a:rPr lang="en-US" smtClean="0"/>
               <a:t>Third level</a:t>
             </a:r>
           </a:p>
           <a:p>
             <a:pPr lvl="3"/>
             <a:r>
-              <a:rPr lang="en-US"/>
+              <a:rPr lang="en-US" smtClean="0"/>
               <a:t>Fourth level</a:t>
             </a:r>
           </a:p>
           <a:p>
             <a:pPr lvl="4"/>
             <a:r>
-              <a:rPr lang="en-US"/>
+              <a:rPr lang="en-US" smtClean="0"/>
               <a:t>Fifth level</a:t>
             </a:r>
+            <a:endParaRPr lang="en-US"/>
           </a:p>
         </p:txBody>
       </p:sp>
@@ -648,7 +638,7 @@
           <a:p>
             <a:fld id="{5BCAD085-E8A6-8845-BD4E-CB4CCA059FC4}" type="datetimeFigureOut">
               <a:rPr lang="en-US" smtClean="0"/>
-              <a:t>6/15/2026</a:t>
+              <a:t>1/27/13</a:t>
             </a:fld>
             <a:endParaRPr lang="en-US"/>
           </a:p>
@@ -742,9 +732,10 @@
           <a:lstStyle/>
           <a:p>
             <a:r>
-              <a:rPr lang="en-US"/>
+              <a:rPr lang="en-US" smtClean="0"/>
               <a:t>Click to edit Master title style</a:t>
             </a:r>
+            <a:endParaRPr lang="en-US"/>
           </a:p>
         </p:txBody>
       </p:sp>
@@ -765,37 +756,38 @@
           <a:p>
             <a:pPr lvl="0"/>
             <a:r>
-              <a:rPr lang="en-US"/>
+              <a:rPr lang="en-US" smtClean="0"/>
               <a:t>Click to edit Master text styles</a:t>
             </a:r>
           </a:p>
           <a:p>
             <a:pPr lvl="1"/>
             <a:r>
-              <a:rPr lang="en-US"/>
+              <a:rPr lang="en-US" smtClean="0"/>
               <a:t>Second level</a:t>
             </a:r>
           </a:p>
           <a:p>
             <a:pPr lvl="2"/>
             <a:r>
-              <a:rPr lang="en-US"/>
+              <a:rPr lang="en-US" smtClean="0"/>
               <a:t>Third level</a:t>
             </a:r>
           </a:p>
           <a:p>
             <a:pPr lvl="3"/>
             <a:r>
-              <a:rPr lang="en-US"/>
+              <a:rPr lang="en-US" smtClean="0"/>
               <a:t>Fourth level</a:t>
             </a:r>
           </a:p>
           <a:p>
             <a:pPr lvl="4"/>
             <a:r>
-              <a:rPr lang="en-US"/>
+              <a:rPr lang="en-US" smtClean="0"/>
               <a:t>Fifth level</a:t>
             </a:r>
+            <a:endParaRPr lang="en-US"/>
           </a:p>
         </p:txBody>
       </p:sp>
@@ -816,7 +808,7 @@
           <a:p>
             <a:fld id="{5BCAD085-E8A6-8845-BD4E-CB4CCA059FC4}" type="datetimeFigureOut">
               <a:rPr lang="en-US" smtClean="0"/>
-              <a:t>6/15/2026</a:t>
+              <a:t>1/27/13</a:t>
             </a:fld>
             <a:endParaRPr lang="en-US"/>
           </a:p>
@@ -919,9 +911,10 @@
           </a:lstStyle>
           <a:p>
             <a:r>
-              <a:rPr lang="en-US"/>
+              <a:rPr lang="en-US" smtClean="0"/>
               <a:t>Click to edit Master title style</a:t>
             </a:r>
+            <a:endParaRPr lang="en-US"/>
           </a:p>
         </p:txBody>
       </p:sp>
@@ -1038,7 +1031,7 @@
           <a:p>
             <a:pPr lvl="0"/>
             <a:r>
-              <a:rPr lang="en-US"/>
+              <a:rPr lang="en-US" smtClean="0"/>
               <a:t>Click to edit Master text styles</a:t>
             </a:r>
           </a:p>
@@ -1061,7 +1054,7 @@
           <a:p>
             <a:fld id="{5BCAD085-E8A6-8845-BD4E-CB4CCA059FC4}" type="datetimeFigureOut">
               <a:rPr lang="en-US" smtClean="0"/>
-              <a:t>6/15/2026</a:t>
+              <a:t>1/27/13</a:t>
             </a:fld>
             <a:endParaRPr lang="en-US"/>
           </a:p>
@@ -1155,9 +1148,10 @@
           <a:lstStyle/>
           <a:p>
             <a:r>
-              <a:rPr lang="en-US"/>
+              <a:rPr lang="en-US" smtClean="0"/>
               <a:t>Click to edit Master title style</a:t>
             </a:r>
+            <a:endParaRPr lang="en-US"/>
           </a:p>
         </p:txBody>
       </p:sp>
@@ -1211,37 +1205,38 @@
           <a:p>
             <a:pPr lvl="0"/>
             <a:r>
-              <a:rPr lang="en-US"/>
+              <a:rPr lang="en-US" smtClean="0"/>
               <a:t>Click to edit Master text styles</a:t>
             </a:r>
           </a:p>
           <a:p>
             <a:pPr lvl="1"/>
             <a:r>
-              <a:rPr lang="en-US"/>
+              <a:rPr lang="en-US" smtClean="0"/>
               <a:t>Second level</a:t>
             </a:r>
           </a:p>
           <a:p>
             <a:pPr lvl="2"/>
             <a:r>
-              <a:rPr lang="en-US"/>
+              <a:rPr lang="en-US" smtClean="0"/>
               <a:t>Third level</a:t>
             </a:r>
           </a:p>
           <a:p>
             <a:pPr lvl="3"/>
             <a:r>
-              <a:rPr lang="en-US"/>
+              <a:rPr lang="en-US" smtClean="0"/>
               <a:t>Fourth level</a:t>
             </a:r>
           </a:p>
           <a:p>
             <a:pPr lvl="4"/>
             <a:r>
-              <a:rPr lang="en-US"/>
+              <a:rPr lang="en-US" smtClean="0"/>
               <a:t>Fifth level</a:t>
             </a:r>
+            <a:endParaRPr lang="en-US"/>
           </a:p>
         </p:txBody>
       </p:sp>
@@ -1295,37 +1290,38 @@
           <a:p>
             <a:pPr lvl="0"/>
             <a:r>
-              <a:rPr lang="en-US"/>
+              <a:rPr lang="en-US" smtClean="0"/>
               <a:t>Click to edit Master text styles</a:t>
             </a:r>
           </a:p>
           <a:p>
             <a:pPr lvl="1"/>
             <a:r>
-              <a:rPr lang="en-US"/>
+              <a:rPr lang="en-US" smtClean="0"/>
               <a:t>Second level</a:t>
             </a:r>
           </a:p>
           <a:p>
             <a:pPr lvl="2"/>
             <a:r>
-              <a:rPr lang="en-US"/>
+              <a:rPr lang="en-US" smtClean="0"/>
               <a:t>Third level</a:t>
             </a:r>
           </a:p>
           <a:p>
             <a:pPr lvl="3"/>
             <a:r>
-              <a:rPr lang="en-US"/>
+              <a:rPr lang="en-US" smtClean="0"/>
               <a:t>Fourth level</a:t>
             </a:r>
           </a:p>
           <a:p>
             <a:pPr lvl="4"/>
             <a:r>
-              <a:rPr lang="en-US"/>
+              <a:rPr lang="en-US" smtClean="0"/>
               <a:t>Fifth level</a:t>
             </a:r>
+            <a:endParaRPr lang="en-US"/>
           </a:p>
         </p:txBody>
       </p:sp>
@@ -1346,7 +1342,7 @@
           <a:p>
             <a:fld id="{5BCAD085-E8A6-8845-BD4E-CB4CCA059FC4}" type="datetimeFigureOut">
               <a:rPr lang="en-US" smtClean="0"/>
-              <a:t>6/15/2026</a:t>
+              <a:t>1/27/13</a:t>
             </a:fld>
             <a:endParaRPr lang="en-US"/>
           </a:p>
@@ -1444,9 +1440,10 @@
           </a:lstStyle>
           <a:p>
             <a:r>
-              <a:rPr lang="en-US"/>
+              <a:rPr lang="en-US" smtClean="0"/>
               <a:t>Click to edit Master title style</a:t>
             </a:r>
+            <a:endParaRPr lang="en-US"/>
           </a:p>
         </p:txBody>
       </p:sp>
@@ -1509,7 +1506,7 @@
           <a:p>
             <a:pPr lvl="0"/>
             <a:r>
-              <a:rPr lang="en-US"/>
+              <a:rPr lang="en-US" smtClean="0"/>
               <a:t>Click to edit Master text styles</a:t>
             </a:r>
           </a:p>
@@ -1565,37 +1562,38 @@
           <a:p>
             <a:pPr lvl="0"/>
             <a:r>
-              <a:rPr lang="en-US"/>
+              <a:rPr lang="en-US" smtClean="0"/>
               <a:t>Click to edit Master text styles</a:t>
             </a:r>
           </a:p>
           <a:p>
             <a:pPr lvl="1"/>
             <a:r>
-              <a:rPr lang="en-US"/>
+              <a:rPr lang="en-US" smtClean="0"/>
               <a:t>Second level</a:t>
             </a:r>
           </a:p>
           <a:p>
             <a:pPr lvl="2"/>
             <a:r>
-              <a:rPr lang="en-US"/>
+              <a:rPr lang="en-US" smtClean="0"/>
               <a:t>Third level</a:t>
             </a:r>
           </a:p>
           <a:p>
             <a:pPr lvl="3"/>
             <a:r>
-              <a:rPr lang="en-US"/>
+              <a:rPr lang="en-US" smtClean="0"/>
               <a:t>Fourth level</a:t>
             </a:r>
           </a:p>
           <a:p>
             <a:pPr lvl="4"/>
             <a:r>
-              <a:rPr lang="en-US"/>
+              <a:rPr lang="en-US" smtClean="0"/>
               <a:t>Fifth level</a:t>
             </a:r>
+            <a:endParaRPr lang="en-US"/>
           </a:p>
         </p:txBody>
       </p:sp>
@@ -1658,7 +1656,7 @@
           <a:p>
             <a:pPr lvl="0"/>
             <a:r>
-              <a:rPr lang="en-US"/>
+              <a:rPr lang="en-US" smtClean="0"/>
               <a:t>Click to edit Master text styles</a:t>
             </a:r>
           </a:p>
@@ -1714,37 +1712,38 @@
           <a:p>
             <a:pPr lvl="0"/>
             <a:r>
-              <a:rPr lang="en-US"/>
+              <a:rPr lang="en-US" smtClean="0"/>
               <a:t>Click to edit Master text styles</a:t>
             </a:r>
           </a:p>
           <a:p>
             <a:pPr lvl="1"/>
             <a:r>
-              <a:rPr lang="en-US"/>
+              <a:rPr lang="en-US" smtClean="0"/>
               <a:t>Second level</a:t>
             </a:r>
           </a:p>
           <a:p>
             <a:pPr lvl="2"/>
             <a:r>
-              <a:rPr lang="en-US"/>
+              <a:rPr lang="en-US" smtClean="0"/>
               <a:t>Third level</a:t>
             </a:r>
           </a:p>
           <a:p>
             <a:pPr lvl="3"/>
             <a:r>
-              <a:rPr lang="en-US"/>
+              <a:rPr lang="en-US" smtClean="0"/>
               <a:t>Fourth level</a:t>
             </a:r>
           </a:p>
           <a:p>
             <a:pPr lvl="4"/>
             <a:r>
-              <a:rPr lang="en-US"/>
+              <a:rPr lang="en-US" smtClean="0"/>
               <a:t>Fifth level</a:t>
             </a:r>
+            <a:endParaRPr lang="en-US"/>
           </a:p>
         </p:txBody>
       </p:sp>
@@ -1765,7 +1764,7 @@
           <a:p>
             <a:fld id="{5BCAD085-E8A6-8845-BD4E-CB4CCA059FC4}" type="datetimeFigureOut">
               <a:rPr lang="en-US" smtClean="0"/>
-              <a:t>6/15/2026</a:t>
+              <a:t>1/27/13</a:t>
             </a:fld>
             <a:endParaRPr lang="en-US"/>
           </a:p>
@@ -1859,9 +1858,10 @@
           <a:lstStyle/>
           <a:p>
             <a:r>
-              <a:rPr lang="en-US"/>
+              <a:rPr lang="en-US" smtClean="0"/>
               <a:t>Click to edit Master title style</a:t>
             </a:r>
+            <a:endParaRPr lang="en-US"/>
           </a:p>
         </p:txBody>
       </p:sp>
@@ -1882,7 +1882,7 @@
           <a:p>
             <a:fld id="{5BCAD085-E8A6-8845-BD4E-CB4CCA059FC4}" type="datetimeFigureOut">
               <a:rPr lang="en-US" smtClean="0"/>
-              <a:t>6/15/2026</a:t>
+              <a:t>1/27/13</a:t>
             </a:fld>
             <a:endParaRPr lang="en-US"/>
           </a:p>
@@ -1977,7 +1977,7 @@
           <a:p>
             <a:fld id="{5BCAD085-E8A6-8845-BD4E-CB4CCA059FC4}" type="datetimeFigureOut">
               <a:rPr lang="en-US" smtClean="0"/>
-              <a:t>6/15/2026</a:t>
+              <a:t>1/27/13</a:t>
             </a:fld>
             <a:endParaRPr lang="en-US"/>
           </a:p>
@@ -2080,9 +2080,10 @@
           </a:lstStyle>
           <a:p>
             <a:r>
-              <a:rPr lang="en-US"/>
+              <a:rPr lang="en-US" smtClean="0"/>
               <a:t>Click to edit Master title style</a:t>
             </a:r>
+            <a:endParaRPr lang="en-US"/>
           </a:p>
         </p:txBody>
       </p:sp>
@@ -2136,37 +2137,38 @@
           <a:p>
             <a:pPr lvl="0"/>
             <a:r>
-              <a:rPr lang="en-US"/>
+              <a:rPr lang="en-US" smtClean="0"/>
               <a:t>Click to edit Master text styles</a:t>
             </a:r>
           </a:p>
           <a:p>
             <a:pPr lvl="1"/>
             <a:r>
-              <a:rPr lang="en-US"/>
+              <a:rPr lang="en-US" smtClean="0"/>
               <a:t>Second level</a:t>
             </a:r>
           </a:p>
           <a:p>
             <a:pPr lvl="2"/>
             <a:r>
-              <a:rPr lang="en-US"/>
+              <a:rPr lang="en-US" smtClean="0"/>
               <a:t>Third level</a:t>
             </a:r>
           </a:p>
           <a:p>
             <a:pPr lvl="3"/>
             <a:r>
-              <a:rPr lang="en-US"/>
+              <a:rPr lang="en-US" smtClean="0"/>
               <a:t>Fourth level</a:t>
             </a:r>
           </a:p>
           <a:p>
             <a:pPr lvl="4"/>
             <a:r>
-              <a:rPr lang="en-US"/>
+              <a:rPr lang="en-US" smtClean="0"/>
               <a:t>Fifth level</a:t>
             </a:r>
+            <a:endParaRPr lang="en-US"/>
           </a:p>
         </p:txBody>
       </p:sp>
@@ -2229,7 +2231,7 @@
           <a:p>
             <a:pPr lvl="0"/>
             <a:r>
-              <a:rPr lang="en-US"/>
+              <a:rPr lang="en-US" smtClean="0"/>
               <a:t>Click to edit Master text styles</a:t>
             </a:r>
           </a:p>
@@ -2252,7 +2254,7 @@
           <a:p>
             <a:fld id="{5BCAD085-E8A6-8845-BD4E-CB4CCA059FC4}" type="datetimeFigureOut">
               <a:rPr lang="en-US" smtClean="0"/>
-              <a:t>6/15/2026</a:t>
+              <a:t>1/27/13</a:t>
             </a:fld>
             <a:endParaRPr lang="en-US"/>
           </a:p>
@@ -2355,9 +2357,10 @@
           </a:lstStyle>
           <a:p>
             <a:r>
-              <a:rPr lang="en-US"/>
+              <a:rPr lang="en-US" smtClean="0"/>
               <a:t>Click to edit Master title style</a:t>
             </a:r>
+            <a:endParaRPr lang="en-US"/>
           </a:p>
         </p:txBody>
       </p:sp>
@@ -2481,7 +2484,7 @@
           <a:p>
             <a:pPr lvl="0"/>
             <a:r>
-              <a:rPr lang="en-US"/>
+              <a:rPr lang="en-US" smtClean="0"/>
               <a:t>Click to edit Master text styles</a:t>
             </a:r>
           </a:p>
@@ -2504,7 +2507,7 @@
           <a:p>
             <a:fld id="{5BCAD085-E8A6-8845-BD4E-CB4CCA059FC4}" type="datetimeFigureOut">
               <a:rPr lang="en-US" smtClean="0"/>
-              <a:t>6/15/2026</a:t>
+              <a:t>1/27/13</a:t>
             </a:fld>
             <a:endParaRPr lang="en-US"/>
           </a:p>
@@ -2613,9 +2616,10 @@
           <a:lstStyle/>
           <a:p>
             <a:r>
-              <a:rPr lang="en-US"/>
+              <a:rPr lang="en-US" smtClean="0"/>
               <a:t>Click to edit Master title style</a:t>
             </a:r>
+            <a:endParaRPr lang="en-US"/>
           </a:p>
         </p:txBody>
       </p:sp>
@@ -2646,37 +2650,38 @@
           <a:p>
             <a:pPr lvl="0"/>
             <a:r>
-              <a:rPr lang="en-US"/>
+              <a:rPr lang="en-US" smtClean="0"/>
               <a:t>Click to edit Master text styles</a:t>
             </a:r>
           </a:p>
           <a:p>
             <a:pPr lvl="1"/>
             <a:r>
-              <a:rPr lang="en-US"/>
+              <a:rPr lang="en-US" smtClean="0"/>
               <a:t>Second level</a:t>
             </a:r>
           </a:p>
           <a:p>
             <a:pPr lvl="2"/>
             <a:r>
-              <a:rPr lang="en-US"/>
+              <a:rPr lang="en-US" smtClean="0"/>
               <a:t>Third level</a:t>
             </a:r>
           </a:p>
           <a:p>
             <a:pPr lvl="3"/>
             <a:r>
-              <a:rPr lang="en-US"/>
+              <a:rPr lang="en-US" smtClean="0"/>
               <a:t>Fourth level</a:t>
             </a:r>
           </a:p>
           <a:p>
             <a:pPr lvl="4"/>
             <a:r>
-              <a:rPr lang="en-US"/>
+              <a:rPr lang="en-US" smtClean="0"/>
               <a:t>Fifth level</a:t>
             </a:r>
+            <a:endParaRPr lang="en-US"/>
           </a:p>
         </p:txBody>
       </p:sp>
@@ -2715,7 +2720,7 @@
           <a:p>
             <a:fld id="{5BCAD085-E8A6-8845-BD4E-CB4CCA059FC4}" type="datetimeFigureOut">
               <a:rPr lang="en-US" smtClean="0"/>
-              <a:t>6/15/2026</a:t>
+              <a:t>1/27/13</a:t>
             </a:fld>
             <a:endParaRPr lang="en-US"/>
           </a:p>
@@ -3074,7 +3079,7 @@
 </file>
 
 <file path=ppt/slides/slide1.xml><?xml version="1.0" encoding="utf-8"?>
-<p:sld xmlns:a="http://schemas.openxmlformats.org/drawingml/2006/main" xmlns:r="http://schemas.openxmlformats.org/officeDocument/2006/relationships" xmlns:p="http://schemas.openxmlformats.org/presentationml/2006/main">
+<p:sld xmlns:a="http://schemas.openxmlformats.org/drawingml/2006/main" xmlns:p="http://schemas.openxmlformats.org/presentationml/2006/main" xmlns:r="http://schemas.openxmlformats.org/officeDocument/2006/relationships">
   <p:cSld>
     <p:spTree>
       <p:nvGrpSpPr>
@@ -3082,14 +3087,7 @@
         <p:cNvGrpSpPr/>
         <p:nvPr/>
       </p:nvGrpSpPr>
-      <p:grpSpPr>
-        <a:xfrm>
-          <a:off x="0" y="0"/>
-          <a:ext cx="0" cy="0"/>
-          <a:chOff x="0" y="0"/>
-          <a:chExt cx="0" cy="0"/>
-        </a:xfrm>
-      </p:grpSpPr>
+      <p:grpSpPr/>
       <p:sp>
         <p:nvSpPr>
           <p:cNvPr id="2" name="Rectangle 1"/>
@@ -3131,7 +3129,6 @@
           <a:lstStyle/>
           <a:p>
             <a:pPr algn="ctr"/>
-            <a:endParaRPr/>
           </a:p>
         </p:txBody>
       </p:sp>
@@ -3152,7 +3149,7 @@
           <a:noFill/>
         </p:spPr>
         <p:txBody>
-          <a:bodyPr wrap="square" lIns="50800" tIns="12700" rIns="50800" bIns="12700" anchor="ctr">
+          <a:bodyPr wrap="square" anchor="ctr" lIns="50800" rIns="50800" tIns="12700" bIns="12700">
             <a:spAutoFit/>
           </a:bodyPr>
           <a:lstStyle/>
@@ -3215,7 +3212,6 @@
           <a:lstStyle/>
           <a:p>
             <a:pPr algn="ctr"/>
-            <a:endParaRPr/>
           </a:p>
         </p:txBody>
       </p:sp>
@@ -3236,7 +3232,7 @@
           <a:noFill/>
         </p:spPr>
         <p:txBody>
-          <a:bodyPr wrap="square" lIns="50800" tIns="12700" rIns="50800" bIns="12700" anchor="ctr">
+          <a:bodyPr wrap="square" anchor="ctr" lIns="50800" rIns="50800" tIns="12700" bIns="12700">
             <a:spAutoFit/>
           </a:bodyPr>
           <a:lstStyle/>
@@ -3319,7 +3315,6 @@
           <a:lstStyle/>
           <a:p>
             <a:pPr algn="ctr"/>
-            <a:endParaRPr/>
           </a:p>
         </p:txBody>
       </p:sp>
@@ -3390,7 +3385,6 @@
           <a:lstStyle/>
           <a:p>
             <a:pPr algn="ctr"/>
-            <a:endParaRPr/>
           </a:p>
         </p:txBody>
       </p:sp>
@@ -3411,7 +3405,7 @@
           <a:noFill/>
         </p:spPr>
         <p:txBody>
-          <a:bodyPr wrap="square" lIns="50800" tIns="12700" rIns="50800" bIns="12700" anchor="ctr">
+          <a:bodyPr wrap="square" anchor="ctr" lIns="50800" rIns="50800" tIns="12700" bIns="12700">
             <a:spAutoFit/>
           </a:bodyPr>
           <a:lstStyle/>
@@ -3476,7 +3470,6 @@
           <a:lstStyle/>
           <a:p>
             <a:pPr algn="ctr"/>
-            <a:endParaRPr/>
           </a:p>
         </p:txBody>
       </p:sp>
@@ -3497,7 +3490,7 @@
           <a:noFill/>
         </p:spPr>
         <p:txBody>
-          <a:bodyPr wrap="square" lIns="50800" tIns="12700" rIns="50800" bIns="12700" anchor="ctr">
+          <a:bodyPr wrap="square" anchor="ctr" lIns="50800" rIns="50800" tIns="12700" bIns="12700">
             <a:spAutoFit/>
           </a:bodyPr>
           <a:lstStyle/>
@@ -3562,7 +3555,6 @@
           <a:lstStyle/>
           <a:p>
             <a:pPr algn="ctr"/>
-            <a:endParaRPr/>
           </a:p>
         </p:txBody>
       </p:sp>
@@ -3583,7 +3575,7 @@
           <a:noFill/>
         </p:spPr>
         <p:txBody>
-          <a:bodyPr wrap="square" lIns="50800" tIns="12700" rIns="50800" bIns="12700" anchor="ctr">
+          <a:bodyPr wrap="square" anchor="ctr" lIns="50800" rIns="50800" tIns="12700" bIns="12700">
             <a:spAutoFit/>
           </a:bodyPr>
           <a:lstStyle/>
@@ -3648,7 +3640,6 @@
           <a:lstStyle/>
           <a:p>
             <a:pPr algn="ctr"/>
-            <a:endParaRPr/>
           </a:p>
         </p:txBody>
       </p:sp>
@@ -3669,7 +3660,7 @@
           <a:noFill/>
         </p:spPr>
         <p:txBody>
-          <a:bodyPr wrap="square" lIns="50800" tIns="12700" rIns="50800" bIns="12700" anchor="ctr">
+          <a:bodyPr wrap="square" anchor="ctr" lIns="50800" rIns="50800" tIns="12700" bIns="12700">
             <a:spAutoFit/>
           </a:bodyPr>
           <a:lstStyle/>
@@ -3734,7 +3725,6 @@
           <a:lstStyle/>
           <a:p>
             <a:pPr algn="ctr"/>
-            <a:endParaRPr/>
           </a:p>
         </p:txBody>
       </p:sp>
@@ -3755,7 +3745,7 @@
           <a:noFill/>
         </p:spPr>
         <p:txBody>
-          <a:bodyPr wrap="square" lIns="50800" tIns="12700" rIns="50800" bIns="12700" anchor="ctr">
+          <a:bodyPr wrap="square" anchor="ctr" lIns="50800" rIns="50800" tIns="12700" bIns="12700">
             <a:spAutoFit/>
           </a:bodyPr>
           <a:lstStyle/>
@@ -3820,7 +3810,6 @@
           <a:lstStyle/>
           <a:p>
             <a:pPr algn="ctr"/>
-            <a:endParaRPr/>
           </a:p>
         </p:txBody>
       </p:sp>
@@ -3841,7 +3830,7 @@
           <a:noFill/>
         </p:spPr>
         <p:txBody>
-          <a:bodyPr wrap="square" lIns="50800" tIns="12700" rIns="50800" bIns="12700" anchor="ctr">
+          <a:bodyPr wrap="square" anchor="ctr" lIns="50800" rIns="50800" tIns="12700" bIns="12700">
             <a:spAutoFit/>
           </a:bodyPr>
           <a:lstStyle/>
@@ -3906,7 +3895,6 @@
           <a:lstStyle/>
           <a:p>
             <a:pPr algn="ctr"/>
-            <a:endParaRPr/>
           </a:p>
         </p:txBody>
       </p:sp>
@@ -3927,7 +3915,7 @@
           <a:noFill/>
         </p:spPr>
         <p:txBody>
-          <a:bodyPr wrap="square" lIns="50800" tIns="12700" rIns="50800" bIns="12700" anchor="ctr">
+          <a:bodyPr wrap="square" anchor="ctr" lIns="50800" rIns="50800" tIns="12700" bIns="12700">
             <a:spAutoFit/>
           </a:bodyPr>
           <a:lstStyle/>
@@ -3992,7 +3980,6 @@
           <a:lstStyle/>
           <a:p>
             <a:pPr algn="ctr"/>
-            <a:endParaRPr/>
           </a:p>
         </p:txBody>
       </p:sp>
@@ -4013,7 +4000,7 @@
           <a:noFill/>
         </p:spPr>
         <p:txBody>
-          <a:bodyPr wrap="square" lIns="50800" tIns="12700" rIns="50800" bIns="12700" anchor="ctr">
+          <a:bodyPr wrap="square" anchor="ctr" lIns="50800" rIns="50800" tIns="12700" bIns="12700">
             <a:spAutoFit/>
           </a:bodyPr>
           <a:lstStyle/>
@@ -4078,7 +4065,6 @@
           <a:lstStyle/>
           <a:p>
             <a:pPr algn="ctr"/>
-            <a:endParaRPr/>
           </a:p>
         </p:txBody>
       </p:sp>
@@ -4099,7 +4085,7 @@
           <a:noFill/>
         </p:spPr>
         <p:txBody>
-          <a:bodyPr wrap="square" lIns="50800" tIns="12700" rIns="50800" bIns="12700" anchor="ctr">
+          <a:bodyPr wrap="square" anchor="ctr" lIns="50800" rIns="50800" tIns="12700" bIns="12700">
             <a:spAutoFit/>
           </a:bodyPr>
           <a:lstStyle/>
@@ -4164,7 +4150,6 @@
           <a:lstStyle/>
           <a:p>
             <a:pPr algn="ctr"/>
-            <a:endParaRPr/>
           </a:p>
         </p:txBody>
       </p:sp>
@@ -4185,7 +4170,7 @@
           <a:noFill/>
         </p:spPr>
         <p:txBody>
-          <a:bodyPr wrap="square" lIns="50800" tIns="12700" rIns="50800" bIns="12700" anchor="ctr">
+          <a:bodyPr wrap="square" anchor="ctr" lIns="50800" rIns="50800" tIns="12700" bIns="12700">
             <a:spAutoFit/>
           </a:bodyPr>
           <a:lstStyle/>
@@ -4250,7 +4235,6 @@
           <a:lstStyle/>
           <a:p>
             <a:pPr algn="ctr"/>
-            <a:endParaRPr/>
           </a:p>
         </p:txBody>
       </p:sp>
@@ -4271,7 +4255,7 @@
           <a:noFill/>
         </p:spPr>
         <p:txBody>
-          <a:bodyPr wrap="square" lIns="50800" tIns="12700" rIns="50800" bIns="12700" anchor="ctr">
+          <a:bodyPr wrap="square" anchor="ctr" lIns="50800" rIns="50800" tIns="12700" bIns="12700">
             <a:spAutoFit/>
           </a:bodyPr>
           <a:lstStyle/>
@@ -4336,7 +4320,6 @@
           <a:lstStyle/>
           <a:p>
             <a:pPr algn="ctr"/>
-            <a:endParaRPr/>
           </a:p>
         </p:txBody>
       </p:sp>
@@ -4357,7 +4340,7 @@
           <a:noFill/>
         </p:spPr>
         <p:txBody>
-          <a:bodyPr wrap="square" lIns="50800" tIns="12700" rIns="50800" bIns="12700" anchor="ctr">
+          <a:bodyPr wrap="square" anchor="ctr" lIns="50800" rIns="50800" tIns="12700" bIns="12700">
             <a:spAutoFit/>
           </a:bodyPr>
           <a:lstStyle/>
@@ -4422,7 +4405,6 @@
           <a:lstStyle/>
           <a:p>
             <a:pPr algn="ctr"/>
-            <a:endParaRPr/>
           </a:p>
         </p:txBody>
       </p:sp>
@@ -4443,7 +4425,7 @@
           <a:noFill/>
         </p:spPr>
         <p:txBody>
-          <a:bodyPr wrap="square" lIns="50800" tIns="12700" rIns="50800" bIns="12700" anchor="ctr">
+          <a:bodyPr wrap="square" anchor="ctr" lIns="50800" rIns="50800" tIns="12700" bIns="12700">
             <a:spAutoFit/>
           </a:bodyPr>
           <a:lstStyle/>
@@ -4453,7 +4435,15 @@
                 <a:spcPts val="200"/>
               </a:spcAft>
             </a:pPr>
-            <a:endParaRPr/>
+            <a:r>
+              <a:rPr sz="950" b="0">
+                <a:solidFill>
+                  <a:srgbClr val="0A0A0A"/>
+                </a:solidFill>
+                <a:latin typeface="맑은 고딕"/>
+              </a:rPr>
+              <a:t/>
+            </a:r>
           </a:p>
         </p:txBody>
       </p:sp>
@@ -4500,7 +4490,6 @@
           <a:lstStyle/>
           <a:p>
             <a:pPr algn="ctr"/>
-            <a:endParaRPr/>
           </a:p>
         </p:txBody>
       </p:sp>
@@ -4521,7 +4510,7 @@
           <a:noFill/>
         </p:spPr>
         <p:txBody>
-          <a:bodyPr wrap="square" lIns="50800" tIns="12700" rIns="50800" bIns="12700" anchor="ctr">
+          <a:bodyPr wrap="square" anchor="ctr" lIns="50800" rIns="50800" tIns="12700" bIns="12700">
             <a:spAutoFit/>
           </a:bodyPr>
           <a:lstStyle/>
@@ -4586,7 +4575,6 @@
           <a:lstStyle/>
           <a:p>
             <a:pPr algn="ctr"/>
-            <a:endParaRPr/>
           </a:p>
         </p:txBody>
       </p:sp>
@@ -4607,7 +4595,7 @@
           <a:noFill/>
         </p:spPr>
         <p:txBody>
-          <a:bodyPr wrap="square" lIns="50800" tIns="12700" rIns="50800" bIns="12700" anchor="ctr">
+          <a:bodyPr wrap="square" anchor="ctr" lIns="50800" rIns="50800" tIns="12700" bIns="12700">
             <a:spAutoFit/>
           </a:bodyPr>
           <a:lstStyle/>
@@ -4672,7 +4660,6 @@
           <a:lstStyle/>
           <a:p>
             <a:pPr algn="ctr"/>
-            <a:endParaRPr/>
           </a:p>
         </p:txBody>
       </p:sp>
@@ -4693,7 +4680,7 @@
           <a:noFill/>
         </p:spPr>
         <p:txBody>
-          <a:bodyPr wrap="square" lIns="50800" tIns="12700" rIns="50800" bIns="12700" anchor="ctr">
+          <a:bodyPr wrap="square" anchor="ctr" lIns="50800" rIns="50800" tIns="12700" bIns="12700">
             <a:spAutoFit/>
           </a:bodyPr>
           <a:lstStyle/>
@@ -4758,7 +4745,6 @@
           <a:lstStyle/>
           <a:p>
             <a:pPr algn="ctr"/>
-            <a:endParaRPr/>
           </a:p>
         </p:txBody>
       </p:sp>
@@ -4779,7 +4765,7 @@
           <a:noFill/>
         </p:spPr>
         <p:txBody>
-          <a:bodyPr wrap="square" lIns="50800" tIns="12700" rIns="50800" bIns="12700" anchor="ctr">
+          <a:bodyPr wrap="square" anchor="ctr" lIns="50800" rIns="50800" tIns="12700" bIns="12700">
             <a:spAutoFit/>
           </a:bodyPr>
           <a:lstStyle/>
@@ -4844,7 +4830,6 @@
           <a:lstStyle/>
           <a:p>
             <a:pPr algn="ctr"/>
-            <a:endParaRPr/>
           </a:p>
         </p:txBody>
       </p:sp>
@@ -4865,7 +4850,7 @@
           <a:noFill/>
         </p:spPr>
         <p:txBody>
-          <a:bodyPr wrap="square" lIns="50800" tIns="12700" rIns="50800" bIns="12700" anchor="ctr">
+          <a:bodyPr wrap="square" anchor="ctr" lIns="50800" rIns="50800" tIns="12700" bIns="12700">
             <a:spAutoFit/>
           </a:bodyPr>
           <a:lstStyle/>
@@ -4930,7 +4915,6 @@
           <a:lstStyle/>
           <a:p>
             <a:pPr algn="ctr"/>
-            <a:endParaRPr/>
           </a:p>
         </p:txBody>
       </p:sp>
@@ -4951,7 +4935,7 @@
           <a:noFill/>
         </p:spPr>
         <p:txBody>
-          <a:bodyPr wrap="square" lIns="50800" tIns="12700" rIns="50800" bIns="12700" anchor="ctr">
+          <a:bodyPr wrap="square" anchor="ctr" lIns="50800" rIns="50800" tIns="12700" bIns="12700">
             <a:spAutoFit/>
           </a:bodyPr>
           <a:lstStyle/>
@@ -4961,7 +4945,15 @@
                 <a:spcPts val="200"/>
               </a:spcAft>
             </a:pPr>
-            <a:endParaRPr/>
+            <a:r>
+              <a:rPr sz="950" b="0">
+                <a:solidFill>
+                  <a:srgbClr val="0A0A0A"/>
+                </a:solidFill>
+                <a:latin typeface="맑은 고딕"/>
+              </a:rPr>
+              <a:t/>
+            </a:r>
           </a:p>
         </p:txBody>
       </p:sp>
@@ -5008,7 +5000,6 @@
           <a:lstStyle/>
           <a:p>
             <a:pPr algn="ctr"/>
-            <a:endParaRPr/>
           </a:p>
         </p:txBody>
       </p:sp>
@@ -5029,7 +5020,7 @@
           <a:noFill/>
         </p:spPr>
         <p:txBody>
-          <a:bodyPr wrap="square" lIns="50800" tIns="12700" rIns="50800" bIns="12700" anchor="ctr">
+          <a:bodyPr wrap="square" anchor="ctr" lIns="50800" rIns="50800" tIns="12700" bIns="12700">
             <a:spAutoFit/>
           </a:bodyPr>
           <a:lstStyle/>
@@ -5094,7 +5085,6 @@
           <a:lstStyle/>
           <a:p>
             <a:pPr algn="ctr"/>
-            <a:endParaRPr/>
           </a:p>
         </p:txBody>
       </p:sp>
@@ -5115,7 +5105,7 @@
           <a:noFill/>
         </p:spPr>
         <p:txBody>
-          <a:bodyPr wrap="square" lIns="50800" tIns="12700" rIns="50800" bIns="12700" anchor="ctr">
+          <a:bodyPr wrap="square" anchor="ctr" lIns="50800" rIns="50800" tIns="12700" bIns="12700">
             <a:spAutoFit/>
           </a:bodyPr>
           <a:lstStyle/>
@@ -5180,7 +5170,6 @@
           <a:lstStyle/>
           <a:p>
             <a:pPr algn="ctr"/>
-            <a:endParaRPr/>
           </a:p>
         </p:txBody>
       </p:sp>
@@ -5201,7 +5190,7 @@
           <a:noFill/>
         </p:spPr>
         <p:txBody>
-          <a:bodyPr wrap="square" lIns="50800" tIns="12700" rIns="50800" bIns="12700" anchor="ctr">
+          <a:bodyPr wrap="square" anchor="ctr" lIns="50800" rIns="50800" tIns="12700" bIns="12700">
             <a:spAutoFit/>
           </a:bodyPr>
           <a:lstStyle/>
@@ -5266,7 +5255,6 @@
           <a:lstStyle/>
           <a:p>
             <a:pPr algn="ctr"/>
-            <a:endParaRPr/>
           </a:p>
         </p:txBody>
       </p:sp>
@@ -5287,7 +5275,7 @@
           <a:noFill/>
         </p:spPr>
         <p:txBody>
-          <a:bodyPr wrap="square" lIns="50800" tIns="12700" rIns="50800" bIns="12700" anchor="ctr">
+          <a:bodyPr wrap="square" anchor="ctr" lIns="50800" rIns="50800" tIns="12700" bIns="12700">
             <a:spAutoFit/>
           </a:bodyPr>
           <a:lstStyle/>
@@ -5352,7 +5340,6 @@
           <a:lstStyle/>
           <a:p>
             <a:pPr algn="ctr"/>
-            <a:endParaRPr/>
           </a:p>
         </p:txBody>
       </p:sp>
@@ -5373,7 +5360,7 @@
           <a:noFill/>
         </p:spPr>
         <p:txBody>
-          <a:bodyPr wrap="square" lIns="50800" tIns="12700" rIns="50800" bIns="12700" anchor="ctr">
+          <a:bodyPr wrap="square" anchor="ctr" lIns="50800" rIns="50800" tIns="12700" bIns="12700">
             <a:spAutoFit/>
           </a:bodyPr>
           <a:lstStyle/>
@@ -5438,7 +5425,6 @@
           <a:lstStyle/>
           <a:p>
             <a:pPr algn="ctr"/>
-            <a:endParaRPr/>
           </a:p>
         </p:txBody>
       </p:sp>
@@ -5459,7 +5445,7 @@
           <a:noFill/>
         </p:spPr>
         <p:txBody>
-          <a:bodyPr wrap="square" lIns="50800" tIns="12700" rIns="50800" bIns="12700" anchor="ctr">
+          <a:bodyPr wrap="square" anchor="ctr" lIns="50800" rIns="50800" tIns="12700" bIns="12700">
             <a:spAutoFit/>
           </a:bodyPr>
           <a:lstStyle/>
@@ -5469,7 +5455,15 @@
                 <a:spcPts val="200"/>
               </a:spcAft>
             </a:pPr>
-            <a:endParaRPr/>
+            <a:r>
+              <a:rPr sz="950" b="0">
+                <a:solidFill>
+                  <a:srgbClr val="0A0A0A"/>
+                </a:solidFill>
+                <a:latin typeface="맑은 고딕"/>
+              </a:rPr>
+              <a:t/>
+            </a:r>
           </a:p>
         </p:txBody>
       </p:sp>
@@ -5516,7 +5510,6 @@
           <a:lstStyle/>
           <a:p>
             <a:pPr algn="ctr"/>
-            <a:endParaRPr/>
           </a:p>
         </p:txBody>
       </p:sp>
@@ -5537,7 +5530,7 @@
           <a:noFill/>
         </p:spPr>
         <p:txBody>
-          <a:bodyPr wrap="square" lIns="50800" tIns="12700" rIns="50800" bIns="12700" anchor="ctr">
+          <a:bodyPr wrap="square" anchor="ctr" lIns="50800" rIns="50800" tIns="12700" bIns="12700">
             <a:spAutoFit/>
           </a:bodyPr>
           <a:lstStyle/>
@@ -5602,7 +5595,6 @@
           <a:lstStyle/>
           <a:p>
             <a:pPr algn="ctr"/>
-            <a:endParaRPr/>
           </a:p>
         </p:txBody>
       </p:sp>
@@ -5623,7 +5615,7 @@
           <a:noFill/>
         </p:spPr>
         <p:txBody>
-          <a:bodyPr wrap="square" lIns="50800" tIns="12700" rIns="50800" bIns="12700" anchor="ctr">
+          <a:bodyPr wrap="square" anchor="ctr" lIns="50800" rIns="50800" tIns="12700" bIns="12700">
             <a:spAutoFit/>
           </a:bodyPr>
           <a:lstStyle/>
@@ -5688,7 +5680,6 @@
           <a:lstStyle/>
           <a:p>
             <a:pPr algn="ctr"/>
-            <a:endParaRPr/>
           </a:p>
         </p:txBody>
       </p:sp>
@@ -5709,7 +5700,7 @@
           <a:noFill/>
         </p:spPr>
         <p:txBody>
-          <a:bodyPr wrap="square" lIns="50800" tIns="12700" rIns="50800" bIns="12700" anchor="ctr">
+          <a:bodyPr wrap="square" anchor="ctr" lIns="50800" rIns="50800" tIns="12700" bIns="12700">
             <a:spAutoFit/>
           </a:bodyPr>
           <a:lstStyle/>
@@ -5774,7 +5765,6 @@
           <a:lstStyle/>
           <a:p>
             <a:pPr algn="ctr"/>
-            <a:endParaRPr/>
           </a:p>
         </p:txBody>
       </p:sp>
@@ -5795,7 +5785,7 @@
           <a:noFill/>
         </p:spPr>
         <p:txBody>
-          <a:bodyPr wrap="square" lIns="50800" tIns="12700" rIns="50800" bIns="12700" anchor="ctr">
+          <a:bodyPr wrap="square" anchor="ctr" lIns="50800" rIns="50800" tIns="12700" bIns="12700">
             <a:spAutoFit/>
           </a:bodyPr>
           <a:lstStyle/>
@@ -5860,7 +5850,6 @@
           <a:lstStyle/>
           <a:p>
             <a:pPr algn="ctr"/>
-            <a:endParaRPr/>
           </a:p>
         </p:txBody>
       </p:sp>
@@ -5881,7 +5870,7 @@
           <a:noFill/>
         </p:spPr>
         <p:txBody>
-          <a:bodyPr wrap="square" lIns="50800" tIns="12700" rIns="50800" bIns="12700" anchor="ctr">
+          <a:bodyPr wrap="square" anchor="ctr" lIns="50800" rIns="50800" tIns="12700" bIns="12700">
             <a:spAutoFit/>
           </a:bodyPr>
           <a:lstStyle/>
@@ -5946,7 +5935,6 @@
           <a:lstStyle/>
           <a:p>
             <a:pPr algn="ctr"/>
-            <a:endParaRPr/>
           </a:p>
         </p:txBody>
       </p:sp>
@@ -5967,7 +5955,7 @@
           <a:noFill/>
         </p:spPr>
         <p:txBody>
-          <a:bodyPr wrap="square" lIns="50800" tIns="12700" rIns="50800" bIns="12700" anchor="ctr">
+          <a:bodyPr wrap="square" anchor="ctr" lIns="50800" rIns="50800" tIns="12700" bIns="12700">
             <a:spAutoFit/>
           </a:bodyPr>
           <a:lstStyle/>
@@ -5977,7 +5965,15 @@
                 <a:spcPts val="200"/>
               </a:spcAft>
             </a:pPr>
-            <a:endParaRPr/>
+            <a:r>
+              <a:rPr sz="950" b="0">
+                <a:solidFill>
+                  <a:srgbClr val="0A0A0A"/>
+                </a:solidFill>
+                <a:latin typeface="맑은 고딕"/>
+              </a:rPr>
+              <a:t/>
+            </a:r>
           </a:p>
         </p:txBody>
       </p:sp>
@@ -6024,7 +6020,6 @@
           <a:lstStyle/>
           <a:p>
             <a:pPr algn="ctr"/>
-            <a:endParaRPr/>
           </a:p>
         </p:txBody>
       </p:sp>
@@ -6045,7 +6040,7 @@
           <a:noFill/>
         </p:spPr>
         <p:txBody>
-          <a:bodyPr wrap="square" lIns="50800" tIns="12700" rIns="50800" bIns="12700" anchor="ctr">
+          <a:bodyPr wrap="square" anchor="ctr" lIns="50800" rIns="50800" tIns="12700" bIns="12700">
             <a:spAutoFit/>
           </a:bodyPr>
           <a:lstStyle/>
@@ -6110,7 +6105,6 @@
           <a:lstStyle/>
           <a:p>
             <a:pPr algn="ctr"/>
-            <a:endParaRPr/>
           </a:p>
         </p:txBody>
       </p:sp>
@@ -6131,7 +6125,7 @@
           <a:noFill/>
         </p:spPr>
         <p:txBody>
-          <a:bodyPr wrap="square" lIns="50800" tIns="12700" rIns="50800" bIns="12700" anchor="ctr">
+          <a:bodyPr wrap="square" anchor="ctr" lIns="50800" rIns="50800" tIns="12700" bIns="12700">
             <a:spAutoFit/>
           </a:bodyPr>
           <a:lstStyle/>
@@ -6196,7 +6190,6 @@
           <a:lstStyle/>
           <a:p>
             <a:pPr algn="ctr"/>
-            <a:endParaRPr/>
           </a:p>
         </p:txBody>
       </p:sp>
@@ -6217,7 +6210,7 @@
           <a:noFill/>
         </p:spPr>
         <p:txBody>
-          <a:bodyPr wrap="square" lIns="50800" tIns="12700" rIns="50800" bIns="12700" anchor="ctr">
+          <a:bodyPr wrap="square" anchor="ctr" lIns="50800" rIns="50800" tIns="12700" bIns="12700">
             <a:spAutoFit/>
           </a:bodyPr>
           <a:lstStyle/>
@@ -6282,7 +6275,6 @@
           <a:lstStyle/>
           <a:p>
             <a:pPr algn="ctr"/>
-            <a:endParaRPr/>
           </a:p>
         </p:txBody>
       </p:sp>
@@ -6303,7 +6295,7 @@
           <a:noFill/>
         </p:spPr>
         <p:txBody>
-          <a:bodyPr wrap="square" lIns="50800" tIns="12700" rIns="50800" bIns="12700" anchor="ctr">
+          <a:bodyPr wrap="square" anchor="ctr" lIns="50800" rIns="50800" tIns="12700" bIns="12700">
             <a:spAutoFit/>
           </a:bodyPr>
           <a:lstStyle/>
@@ -6368,7 +6360,6 @@
           <a:lstStyle/>
           <a:p>
             <a:pPr algn="ctr"/>
-            <a:endParaRPr/>
           </a:p>
         </p:txBody>
       </p:sp>
@@ -6389,7 +6380,7 @@
           <a:noFill/>
         </p:spPr>
         <p:txBody>
-          <a:bodyPr wrap="square" lIns="50800" tIns="12700" rIns="50800" bIns="12700" anchor="ctr">
+          <a:bodyPr wrap="square" anchor="ctr" lIns="50800" rIns="50800" tIns="12700" bIns="12700">
             <a:spAutoFit/>
           </a:bodyPr>
           <a:lstStyle/>
@@ -6454,7 +6445,6 @@
           <a:lstStyle/>
           <a:p>
             <a:pPr algn="ctr"/>
-            <a:endParaRPr/>
           </a:p>
         </p:txBody>
       </p:sp>
@@ -6475,7 +6465,7 @@
           <a:noFill/>
         </p:spPr>
         <p:txBody>
-          <a:bodyPr wrap="square" lIns="50800" tIns="12700" rIns="50800" bIns="12700" anchor="ctr">
+          <a:bodyPr wrap="square" anchor="ctr" lIns="50800" rIns="50800" tIns="12700" bIns="12700">
             <a:spAutoFit/>
           </a:bodyPr>
           <a:lstStyle/>
@@ -6540,7 +6530,6 @@
           <a:lstStyle/>
           <a:p>
             <a:pPr algn="ctr"/>
-            <a:endParaRPr/>
           </a:p>
         </p:txBody>
       </p:sp>
@@ -6561,7 +6550,7 @@
           <a:noFill/>
         </p:spPr>
         <p:txBody>
-          <a:bodyPr wrap="square" lIns="50800" tIns="12700" rIns="50800" bIns="12700" anchor="ctr">
+          <a:bodyPr wrap="square" anchor="ctr" lIns="50800" rIns="50800" tIns="12700" bIns="12700">
             <a:spAutoFit/>
           </a:bodyPr>
           <a:lstStyle/>
@@ -6626,7 +6615,6 @@
           <a:lstStyle/>
           <a:p>
             <a:pPr algn="ctr"/>
-            <a:endParaRPr/>
           </a:p>
         </p:txBody>
       </p:sp>
@@ -6647,7 +6635,7 @@
           <a:noFill/>
         </p:spPr>
         <p:txBody>
-          <a:bodyPr wrap="square" lIns="50800" tIns="12700" rIns="50800" bIns="12700" anchor="ctr">
+          <a:bodyPr wrap="square" anchor="ctr" lIns="50800" rIns="50800" tIns="12700" bIns="12700">
             <a:spAutoFit/>
           </a:bodyPr>
           <a:lstStyle/>
@@ -6712,7 +6700,6 @@
           <a:lstStyle/>
           <a:p>
             <a:pPr algn="ctr"/>
-            <a:endParaRPr/>
           </a:p>
         </p:txBody>
       </p:sp>
@@ -6733,7 +6720,7 @@
           <a:noFill/>
         </p:spPr>
         <p:txBody>
-          <a:bodyPr wrap="square" lIns="50800" tIns="12700" rIns="50800" bIns="12700" anchor="ctr">
+          <a:bodyPr wrap="square" anchor="ctr" lIns="50800" rIns="50800" tIns="12700" bIns="12700">
             <a:spAutoFit/>
           </a:bodyPr>
           <a:lstStyle/>
@@ -6798,7 +6785,6 @@
           <a:lstStyle/>
           <a:p>
             <a:pPr algn="ctr"/>
-            <a:endParaRPr/>
           </a:p>
         </p:txBody>
       </p:sp>
@@ -6819,7 +6805,7 @@
           <a:noFill/>
         </p:spPr>
         <p:txBody>
-          <a:bodyPr wrap="square" lIns="50800" tIns="12700" rIns="50800" bIns="12700" anchor="ctr">
+          <a:bodyPr wrap="square" anchor="ctr" lIns="50800" rIns="50800" tIns="12700" bIns="12700">
             <a:spAutoFit/>
           </a:bodyPr>
           <a:lstStyle/>
@@ -6884,7 +6870,6 @@
           <a:lstStyle/>
           <a:p>
             <a:pPr algn="ctr"/>
-            <a:endParaRPr/>
           </a:p>
         </p:txBody>
       </p:sp>
@@ -6905,7 +6890,7 @@
           <a:noFill/>
         </p:spPr>
         <p:txBody>
-          <a:bodyPr wrap="square" lIns="50800" tIns="12700" rIns="50800" bIns="12700" anchor="ctr">
+          <a:bodyPr wrap="square" anchor="ctr" lIns="50800" rIns="50800" tIns="12700" bIns="12700">
             <a:spAutoFit/>
           </a:bodyPr>
           <a:lstStyle/>
@@ -6970,7 +6955,6 @@
           <a:lstStyle/>
           <a:p>
             <a:pPr algn="ctr"/>
-            <a:endParaRPr/>
           </a:p>
         </p:txBody>
       </p:sp>
@@ -6991,7 +6975,7 @@
           <a:noFill/>
         </p:spPr>
         <p:txBody>
-          <a:bodyPr wrap="square" lIns="50800" tIns="12700" rIns="50800" bIns="12700" anchor="ctr">
+          <a:bodyPr wrap="square" anchor="ctr" lIns="50800" rIns="50800" tIns="12700" bIns="12700">
             <a:spAutoFit/>
           </a:bodyPr>
           <a:lstStyle/>
@@ -7001,7 +6985,15 @@
                 <a:spcPts val="200"/>
               </a:spcAft>
             </a:pPr>
-            <a:endParaRPr/>
+            <a:r>
+              <a:rPr sz="950" b="0">
+                <a:solidFill>
+                  <a:srgbClr val="0A0A0A"/>
+                </a:solidFill>
+                <a:latin typeface="맑은 고딕"/>
+              </a:rPr>
+              <a:t/>
+            </a:r>
           </a:p>
         </p:txBody>
       </p:sp>
@@ -7048,7 +7040,6 @@
           <a:lstStyle/>
           <a:p>
             <a:pPr algn="ctr"/>
-            <a:endParaRPr/>
           </a:p>
         </p:txBody>
       </p:sp>
@@ -7069,7 +7060,7 @@
           <a:noFill/>
         </p:spPr>
         <p:txBody>
-          <a:bodyPr wrap="square" lIns="50800" tIns="12700" rIns="50800" bIns="12700" anchor="ctr">
+          <a:bodyPr wrap="square" anchor="ctr" lIns="50800" rIns="50800" tIns="12700" bIns="12700">
             <a:spAutoFit/>
           </a:bodyPr>
           <a:lstStyle/>
@@ -7134,7 +7125,6 @@
           <a:lstStyle/>
           <a:p>
             <a:pPr algn="ctr"/>
-            <a:endParaRPr/>
           </a:p>
         </p:txBody>
       </p:sp>
@@ -7155,7 +7145,7 @@
           <a:noFill/>
         </p:spPr>
         <p:txBody>
-          <a:bodyPr wrap="square" lIns="50800" tIns="12700" rIns="50800" bIns="12700" anchor="ctr">
+          <a:bodyPr wrap="square" anchor="ctr" lIns="50800" rIns="50800" tIns="12700" bIns="12700">
             <a:spAutoFit/>
           </a:bodyPr>
           <a:lstStyle/>
@@ -7220,7 +7210,6 @@
           <a:lstStyle/>
           <a:p>
             <a:pPr algn="ctr"/>
-            <a:endParaRPr/>
           </a:p>
         </p:txBody>
       </p:sp>
@@ -7241,7 +7230,7 @@
           <a:noFill/>
         </p:spPr>
         <p:txBody>
-          <a:bodyPr wrap="square" lIns="50800" tIns="12700" rIns="50800" bIns="12700" anchor="ctr">
+          <a:bodyPr wrap="square" anchor="ctr" lIns="50800" rIns="50800" tIns="12700" bIns="12700">
             <a:spAutoFit/>
           </a:bodyPr>
           <a:lstStyle/>
@@ -7306,7 +7295,6 @@
           <a:lstStyle/>
           <a:p>
             <a:pPr algn="ctr"/>
-            <a:endParaRPr/>
           </a:p>
         </p:txBody>
       </p:sp>
@@ -7327,7 +7315,7 @@
           <a:noFill/>
         </p:spPr>
         <p:txBody>
-          <a:bodyPr wrap="square" lIns="50800" tIns="12700" rIns="50800" bIns="12700" anchor="ctr">
+          <a:bodyPr wrap="square" anchor="ctr" lIns="50800" rIns="50800" tIns="12700" bIns="12700">
             <a:spAutoFit/>
           </a:bodyPr>
           <a:lstStyle/>
@@ -7392,7 +7380,6 @@
           <a:lstStyle/>
           <a:p>
             <a:pPr algn="ctr"/>
-            <a:endParaRPr/>
           </a:p>
         </p:txBody>
       </p:sp>
@@ -7413,7 +7400,7 @@
           <a:noFill/>
         </p:spPr>
         <p:txBody>
-          <a:bodyPr wrap="square" lIns="50800" tIns="12700" rIns="50800" bIns="12700" anchor="ctr">
+          <a:bodyPr wrap="square" anchor="ctr" lIns="50800" rIns="50800" tIns="12700" bIns="12700">
             <a:spAutoFit/>
           </a:bodyPr>
           <a:lstStyle/>
@@ -7478,7 +7465,6 @@
           <a:lstStyle/>
           <a:p>
             <a:pPr algn="ctr"/>
-            <a:endParaRPr/>
           </a:p>
         </p:txBody>
       </p:sp>
@@ -7499,7 +7485,7 @@
           <a:noFill/>
         </p:spPr>
         <p:txBody>
-          <a:bodyPr wrap="square" lIns="50800" tIns="12700" rIns="50800" bIns="12700" anchor="ctr">
+          <a:bodyPr wrap="square" anchor="ctr" lIns="50800" rIns="50800" tIns="12700" bIns="12700">
             <a:spAutoFit/>
           </a:bodyPr>
           <a:lstStyle/>
@@ -7509,7 +7495,15 @@
                 <a:spcPts val="200"/>
               </a:spcAft>
             </a:pPr>
-            <a:endParaRPr/>
+            <a:r>
+              <a:rPr sz="950" b="0">
+                <a:solidFill>
+                  <a:srgbClr val="0A0A0A"/>
+                </a:solidFill>
+                <a:latin typeface="맑은 고딕"/>
+              </a:rPr>
+              <a:t/>
+            </a:r>
           </a:p>
         </p:txBody>
       </p:sp>
@@ -7556,7 +7550,6 @@
           <a:lstStyle/>
           <a:p>
             <a:pPr algn="ctr"/>
-            <a:endParaRPr/>
           </a:p>
         </p:txBody>
       </p:sp>
@@ -7577,7 +7570,7 @@
           <a:noFill/>
         </p:spPr>
         <p:txBody>
-          <a:bodyPr wrap="square" lIns="50800" tIns="12700" rIns="50800" bIns="12700" anchor="ctr">
+          <a:bodyPr wrap="square" anchor="ctr" lIns="50800" rIns="50800" tIns="12700" bIns="12700">
             <a:spAutoFit/>
           </a:bodyPr>
           <a:lstStyle/>
@@ -7642,7 +7635,6 @@
           <a:lstStyle/>
           <a:p>
             <a:pPr algn="ctr"/>
-            <a:endParaRPr/>
           </a:p>
         </p:txBody>
       </p:sp>
@@ -7663,7 +7655,7 @@
           <a:noFill/>
         </p:spPr>
         <p:txBody>
-          <a:bodyPr wrap="square" lIns="50800" tIns="12700" rIns="50800" bIns="12700" anchor="ctr">
+          <a:bodyPr wrap="square" anchor="ctr" lIns="50800" rIns="50800" tIns="12700" bIns="12700">
             <a:spAutoFit/>
           </a:bodyPr>
           <a:lstStyle/>
@@ -7728,7 +7720,6 @@
           <a:lstStyle/>
           <a:p>
             <a:pPr algn="ctr"/>
-            <a:endParaRPr/>
           </a:p>
         </p:txBody>
       </p:sp>
@@ -7749,7 +7740,7 @@
           <a:noFill/>
         </p:spPr>
         <p:txBody>
-          <a:bodyPr wrap="square" lIns="50800" tIns="12700" rIns="50800" bIns="12700" anchor="ctr">
+          <a:bodyPr wrap="square" anchor="ctr" lIns="50800" rIns="50800" tIns="12700" bIns="12700">
             <a:spAutoFit/>
           </a:bodyPr>
           <a:lstStyle/>
@@ -7814,7 +7805,6 @@
           <a:lstStyle/>
           <a:p>
             <a:pPr algn="ctr"/>
-            <a:endParaRPr/>
           </a:p>
         </p:txBody>
       </p:sp>
@@ -7835,7 +7825,7 @@
           <a:noFill/>
         </p:spPr>
         <p:txBody>
-          <a:bodyPr wrap="square" lIns="50800" tIns="12700" rIns="50800" bIns="12700" anchor="ctr">
+          <a:bodyPr wrap="square" anchor="ctr" lIns="50800" rIns="50800" tIns="12700" bIns="12700">
             <a:spAutoFit/>
           </a:bodyPr>
           <a:lstStyle/>
@@ -7900,7 +7890,6 @@
           <a:lstStyle/>
           <a:p>
             <a:pPr algn="ctr"/>
-            <a:endParaRPr/>
           </a:p>
         </p:txBody>
       </p:sp>
@@ -7921,7 +7910,7 @@
           <a:noFill/>
         </p:spPr>
         <p:txBody>
-          <a:bodyPr wrap="square" lIns="50800" tIns="12700" rIns="50800" bIns="12700" anchor="ctr">
+          <a:bodyPr wrap="square" anchor="ctr" lIns="50800" rIns="50800" tIns="12700" bIns="12700">
             <a:spAutoFit/>
           </a:bodyPr>
           <a:lstStyle/>
@@ -7986,7 +7975,6 @@
           <a:lstStyle/>
           <a:p>
             <a:pPr algn="ctr"/>
-            <a:endParaRPr/>
           </a:p>
         </p:txBody>
       </p:sp>
@@ -8007,7 +7995,7 @@
           <a:noFill/>
         </p:spPr>
         <p:txBody>
-          <a:bodyPr wrap="square" lIns="50800" tIns="12700" rIns="50800" bIns="12700" anchor="ctr">
+          <a:bodyPr wrap="square" anchor="ctr" lIns="50800" rIns="50800" tIns="12700" bIns="12700">
             <a:spAutoFit/>
           </a:bodyPr>
           <a:lstStyle/>
@@ -8017,7 +8005,15 @@
                 <a:spcPts val="200"/>
               </a:spcAft>
             </a:pPr>
-            <a:endParaRPr/>
+            <a:r>
+              <a:rPr sz="950" b="0">
+                <a:solidFill>
+                  <a:srgbClr val="0A0A0A"/>
+                </a:solidFill>
+                <a:latin typeface="맑은 고딕"/>
+              </a:rPr>
+              <a:t/>
+            </a:r>
           </a:p>
         </p:txBody>
       </p:sp>
@@ -8064,7 +8060,6 @@
           <a:lstStyle/>
           <a:p>
             <a:pPr algn="ctr"/>
-            <a:endParaRPr/>
           </a:p>
         </p:txBody>
       </p:sp>
@@ -8085,7 +8080,7 @@
           <a:noFill/>
         </p:spPr>
         <p:txBody>
-          <a:bodyPr wrap="square" lIns="50800" tIns="12700" rIns="50800" bIns="12700" anchor="ctr">
+          <a:bodyPr wrap="square" anchor="ctr" lIns="50800" rIns="50800" tIns="12700" bIns="12700">
             <a:spAutoFit/>
           </a:bodyPr>
           <a:lstStyle/>
@@ -8150,7 +8145,6 @@
           <a:lstStyle/>
           <a:p>
             <a:pPr algn="ctr"/>
-            <a:endParaRPr/>
           </a:p>
         </p:txBody>
       </p:sp>
@@ -8171,7 +8165,7 @@
           <a:noFill/>
         </p:spPr>
         <p:txBody>
-          <a:bodyPr wrap="square" lIns="50800" tIns="12700" rIns="50800" bIns="12700" anchor="ctr">
+          <a:bodyPr wrap="square" anchor="ctr" lIns="50800" rIns="50800" tIns="12700" bIns="12700">
             <a:spAutoFit/>
           </a:bodyPr>
           <a:lstStyle/>
@@ -8236,7 +8230,6 @@
           <a:lstStyle/>
           <a:p>
             <a:pPr algn="ctr"/>
-            <a:endParaRPr/>
           </a:p>
         </p:txBody>
       </p:sp>
@@ -8257,7 +8250,7 @@
           <a:noFill/>
         </p:spPr>
         <p:txBody>
-          <a:bodyPr wrap="square" lIns="50800" tIns="12700" rIns="50800" bIns="12700" anchor="ctr">
+          <a:bodyPr wrap="square" anchor="ctr" lIns="50800" rIns="50800" tIns="12700" bIns="12700">
             <a:spAutoFit/>
           </a:bodyPr>
           <a:lstStyle/>
@@ -8322,7 +8315,6 @@
           <a:lstStyle/>
           <a:p>
             <a:pPr algn="ctr"/>
-            <a:endParaRPr/>
           </a:p>
         </p:txBody>
       </p:sp>
@@ -8343,7 +8335,7 @@
           <a:noFill/>
         </p:spPr>
         <p:txBody>
-          <a:bodyPr wrap="square" lIns="50800" tIns="12700" rIns="50800" bIns="12700" anchor="ctr">
+          <a:bodyPr wrap="square" anchor="ctr" lIns="50800" rIns="50800" tIns="12700" bIns="12700">
             <a:spAutoFit/>
           </a:bodyPr>
           <a:lstStyle/>
@@ -8408,7 +8400,6 @@
           <a:lstStyle/>
           <a:p>
             <a:pPr algn="ctr"/>
-            <a:endParaRPr/>
           </a:p>
         </p:txBody>
       </p:sp>
@@ -8429,7 +8420,7 @@
           <a:noFill/>
         </p:spPr>
         <p:txBody>
-          <a:bodyPr wrap="square" lIns="50800" tIns="12700" rIns="50800" bIns="12700" anchor="ctr">
+          <a:bodyPr wrap="square" anchor="ctr" lIns="50800" rIns="50800" tIns="12700" bIns="12700">
             <a:spAutoFit/>
           </a:bodyPr>
           <a:lstStyle/>
@@ -8494,7 +8485,6 @@
           <a:lstStyle/>
           <a:p>
             <a:pPr algn="ctr"/>
-            <a:endParaRPr/>
           </a:p>
         </p:txBody>
       </p:sp>
@@ -8515,7 +8505,7 @@
           <a:noFill/>
         </p:spPr>
         <p:txBody>
-          <a:bodyPr wrap="square" lIns="50800" tIns="12700" rIns="50800" bIns="12700" anchor="ctr">
+          <a:bodyPr wrap="square" anchor="ctr" lIns="50800" rIns="50800" tIns="12700" bIns="12700">
             <a:spAutoFit/>
           </a:bodyPr>
           <a:lstStyle/>
@@ -8525,7 +8515,15 @@
                 <a:spcPts val="200"/>
               </a:spcAft>
             </a:pPr>
-            <a:endParaRPr/>
+            <a:r>
+              <a:rPr sz="950" b="0">
+                <a:solidFill>
+                  <a:srgbClr val="0A0A0A"/>
+                </a:solidFill>
+                <a:latin typeface="맑은 고딕"/>
+              </a:rPr>
+              <a:t/>
+            </a:r>
           </a:p>
         </p:txBody>
       </p:sp>
@@ -8572,7 +8570,6 @@
           <a:lstStyle/>
           <a:p>
             <a:pPr algn="ctr"/>
-            <a:endParaRPr/>
           </a:p>
         </p:txBody>
       </p:sp>
@@ -8593,7 +8590,7 @@
           <a:noFill/>
         </p:spPr>
         <p:txBody>
-          <a:bodyPr wrap="square" lIns="50800" tIns="12700" rIns="50800" bIns="12700" anchor="ctr">
+          <a:bodyPr wrap="square" anchor="ctr" lIns="50800" rIns="50800" tIns="12700" bIns="12700">
             <a:spAutoFit/>
           </a:bodyPr>
           <a:lstStyle/>
@@ -8658,7 +8655,6 @@
           <a:lstStyle/>
           <a:p>
             <a:pPr algn="ctr"/>
-            <a:endParaRPr/>
           </a:p>
         </p:txBody>
       </p:sp>
@@ -8679,7 +8675,7 @@
           <a:noFill/>
         </p:spPr>
         <p:txBody>
-          <a:bodyPr wrap="square" lIns="50800" tIns="12700" rIns="50800" bIns="12700" anchor="ctr">
+          <a:bodyPr wrap="square" anchor="ctr" lIns="50800" rIns="50800" tIns="12700" bIns="12700">
             <a:spAutoFit/>
           </a:bodyPr>
           <a:lstStyle/>
@@ -8744,7 +8740,6 @@
           <a:lstStyle/>
           <a:p>
             <a:pPr algn="ctr"/>
-            <a:endParaRPr/>
           </a:p>
         </p:txBody>
       </p:sp>
@@ -8765,7 +8760,7 @@
           <a:noFill/>
         </p:spPr>
         <p:txBody>
-          <a:bodyPr wrap="square" lIns="50800" tIns="12700" rIns="50800" bIns="12700" anchor="ctr">
+          <a:bodyPr wrap="square" anchor="ctr" lIns="50800" rIns="50800" tIns="12700" bIns="12700">
             <a:spAutoFit/>
           </a:bodyPr>
           <a:lstStyle/>
@@ -8830,7 +8825,6 @@
           <a:lstStyle/>
           <a:p>
             <a:pPr algn="ctr"/>
-            <a:endParaRPr/>
           </a:p>
         </p:txBody>
       </p:sp>
@@ -8851,7 +8845,7 @@
           <a:noFill/>
         </p:spPr>
         <p:txBody>
-          <a:bodyPr wrap="square" lIns="50800" tIns="12700" rIns="50800" bIns="12700" anchor="ctr">
+          <a:bodyPr wrap="square" anchor="ctr" lIns="50800" rIns="50800" tIns="12700" bIns="12700">
             <a:spAutoFit/>
           </a:bodyPr>
           <a:lstStyle/>
@@ -8916,7 +8910,6 @@
           <a:lstStyle/>
           <a:p>
             <a:pPr algn="ctr"/>
-            <a:endParaRPr/>
           </a:p>
         </p:txBody>
       </p:sp>
@@ -8937,7 +8930,7 @@
           <a:noFill/>
         </p:spPr>
         <p:txBody>
-          <a:bodyPr wrap="square" lIns="50800" tIns="12700" rIns="50800" bIns="12700" anchor="ctr">
+          <a:bodyPr wrap="square" anchor="ctr" lIns="50800" rIns="50800" tIns="12700" bIns="12700">
             <a:spAutoFit/>
           </a:bodyPr>
           <a:lstStyle/>
@@ -9002,7 +8995,6 @@
           <a:lstStyle/>
           <a:p>
             <a:pPr algn="ctr"/>
-            <a:endParaRPr/>
           </a:p>
         </p:txBody>
       </p:sp>
@@ -9023,7 +9015,7 @@
           <a:noFill/>
         </p:spPr>
         <p:txBody>
-          <a:bodyPr wrap="square" lIns="50800" tIns="12700" rIns="50800" bIns="12700" anchor="ctr">
+          <a:bodyPr wrap="square" anchor="ctr" lIns="50800" rIns="50800" tIns="12700" bIns="12700">
             <a:spAutoFit/>
           </a:bodyPr>
           <a:lstStyle/>
@@ -9088,7 +9080,6 @@
           <a:lstStyle/>
           <a:p>
             <a:pPr algn="ctr"/>
-            <a:endParaRPr/>
           </a:p>
         </p:txBody>
       </p:sp>
@@ -9109,7 +9100,7 @@
           <a:noFill/>
         </p:spPr>
         <p:txBody>
-          <a:bodyPr wrap="square" lIns="50800" tIns="12700" rIns="50800" bIns="12700" anchor="ctr">
+          <a:bodyPr wrap="square" anchor="ctr" lIns="50800" rIns="50800" tIns="12700" bIns="12700">
             <a:spAutoFit/>
           </a:bodyPr>
           <a:lstStyle/>
@@ -9174,7 +9165,6 @@
           <a:lstStyle/>
           <a:p>
             <a:pPr algn="ctr"/>
-            <a:endParaRPr/>
           </a:p>
         </p:txBody>
       </p:sp>
@@ -9195,7 +9185,7 @@
           <a:noFill/>
         </p:spPr>
         <p:txBody>
-          <a:bodyPr wrap="square" lIns="50800" tIns="12700" rIns="50800" bIns="12700" anchor="ctr">
+          <a:bodyPr wrap="square" anchor="ctr" lIns="50800" rIns="50800" tIns="12700" bIns="12700">
             <a:spAutoFit/>
           </a:bodyPr>
           <a:lstStyle/>
@@ -9260,7 +9250,6 @@
           <a:lstStyle/>
           <a:p>
             <a:pPr algn="ctr"/>
-            <a:endParaRPr/>
           </a:p>
         </p:txBody>
       </p:sp>
@@ -9281,7 +9270,7 @@
           <a:noFill/>
         </p:spPr>
         <p:txBody>
-          <a:bodyPr wrap="square" lIns="50800" tIns="12700" rIns="50800" bIns="12700" anchor="ctr">
+          <a:bodyPr wrap="square" anchor="ctr" lIns="50800" rIns="50800" tIns="12700" bIns="12700">
             <a:spAutoFit/>
           </a:bodyPr>
           <a:lstStyle/>
@@ -9346,7 +9335,6 @@
           <a:lstStyle/>
           <a:p>
             <a:pPr algn="ctr"/>
-            <a:endParaRPr/>
           </a:p>
         </p:txBody>
       </p:sp>
@@ -9367,7 +9355,7 @@
           <a:noFill/>
         </p:spPr>
         <p:txBody>
-          <a:bodyPr wrap="square" lIns="50800" tIns="12700" rIns="50800" bIns="12700" anchor="ctr">
+          <a:bodyPr wrap="square" anchor="ctr" lIns="50800" rIns="50800" tIns="12700" bIns="12700">
             <a:spAutoFit/>
           </a:bodyPr>
           <a:lstStyle/>
@@ -9432,7 +9420,6 @@
           <a:lstStyle/>
           <a:p>
             <a:pPr algn="ctr"/>
-            <a:endParaRPr/>
           </a:p>
         </p:txBody>
       </p:sp>
@@ -9453,7 +9440,7 @@
           <a:noFill/>
         </p:spPr>
         <p:txBody>
-          <a:bodyPr wrap="square" lIns="50800" tIns="12700" rIns="50800" bIns="12700" anchor="ctr">
+          <a:bodyPr wrap="square" anchor="ctr" lIns="50800" rIns="50800" tIns="12700" bIns="12700">
             <a:spAutoFit/>
           </a:bodyPr>
           <a:lstStyle/>
@@ -9518,7 +9505,6 @@
           <a:lstStyle/>
           <a:p>
             <a:pPr algn="ctr"/>
-            <a:endParaRPr/>
           </a:p>
         </p:txBody>
       </p:sp>
@@ -9539,7 +9525,7 @@
           <a:noFill/>
         </p:spPr>
         <p:txBody>
-          <a:bodyPr wrap="square" lIns="50800" tIns="12700" rIns="50800" bIns="12700" anchor="ctr">
+          <a:bodyPr wrap="square" anchor="ctr" lIns="50800" rIns="50800" tIns="12700" bIns="12700">
             <a:spAutoFit/>
           </a:bodyPr>
           <a:lstStyle/>
@@ -9549,7 +9535,15 @@
                 <a:spcPts val="200"/>
               </a:spcAft>
             </a:pPr>
-            <a:endParaRPr/>
+            <a:r>
+              <a:rPr sz="950" b="0">
+                <a:solidFill>
+                  <a:srgbClr val="0A0A0A"/>
+                </a:solidFill>
+                <a:latin typeface="맑은 고딕"/>
+              </a:rPr>
+              <a:t/>
+            </a:r>
           </a:p>
         </p:txBody>
       </p:sp>
@@ -9596,7 +9590,6 @@
           <a:lstStyle/>
           <a:p>
             <a:pPr algn="ctr"/>
-            <a:endParaRPr/>
           </a:p>
         </p:txBody>
       </p:sp>
@@ -9617,7 +9610,7 @@
           <a:noFill/>
         </p:spPr>
         <p:txBody>
-          <a:bodyPr wrap="square" lIns="50800" tIns="12700" rIns="50800" bIns="12700" anchor="ctr">
+          <a:bodyPr wrap="square" anchor="ctr" lIns="50800" rIns="50800" tIns="12700" bIns="12700">
             <a:spAutoFit/>
           </a:bodyPr>
           <a:lstStyle/>
@@ -9682,7 +9675,6 @@
           <a:lstStyle/>
           <a:p>
             <a:pPr algn="ctr"/>
-            <a:endParaRPr/>
           </a:p>
         </p:txBody>
       </p:sp>
@@ -9703,7 +9695,7 @@
           <a:noFill/>
         </p:spPr>
         <p:txBody>
-          <a:bodyPr wrap="square" lIns="50800" tIns="12700" rIns="50800" bIns="12700" anchor="ctr">
+          <a:bodyPr wrap="square" anchor="ctr" lIns="50800" rIns="50800" tIns="12700" bIns="12700">
             <a:spAutoFit/>
           </a:bodyPr>
           <a:lstStyle/>
@@ -9768,7 +9760,6 @@
           <a:lstStyle/>
           <a:p>
             <a:pPr algn="ctr"/>
-            <a:endParaRPr/>
           </a:p>
         </p:txBody>
       </p:sp>
@@ -9789,7 +9780,7 @@
           <a:noFill/>
         </p:spPr>
         <p:txBody>
-          <a:bodyPr wrap="square" lIns="50800" tIns="12700" rIns="50800" bIns="12700" anchor="ctr">
+          <a:bodyPr wrap="square" anchor="ctr" lIns="50800" rIns="50800" tIns="12700" bIns="12700">
             <a:spAutoFit/>
           </a:bodyPr>
           <a:lstStyle/>
@@ -9854,7 +9845,6 @@
           <a:lstStyle/>
           <a:p>
             <a:pPr algn="ctr"/>
-            <a:endParaRPr/>
           </a:p>
         </p:txBody>
       </p:sp>
@@ -9875,7 +9865,7 @@
           <a:noFill/>
         </p:spPr>
         <p:txBody>
-          <a:bodyPr wrap="square" lIns="50800" tIns="12700" rIns="50800" bIns="12700" anchor="ctr">
+          <a:bodyPr wrap="square" anchor="ctr" lIns="50800" rIns="50800" tIns="12700" bIns="12700">
             <a:spAutoFit/>
           </a:bodyPr>
           <a:lstStyle/>
@@ -9940,7 +9930,6 @@
           <a:lstStyle/>
           <a:p>
             <a:pPr algn="ctr"/>
-            <a:endParaRPr/>
           </a:p>
         </p:txBody>
       </p:sp>
@@ -9961,7 +9950,7 @@
           <a:noFill/>
         </p:spPr>
         <p:txBody>
-          <a:bodyPr wrap="square" lIns="50800" tIns="12700" rIns="50800" bIns="12700" anchor="ctr">
+          <a:bodyPr wrap="square" anchor="ctr" lIns="50800" rIns="50800" tIns="12700" bIns="12700">
             <a:spAutoFit/>
           </a:bodyPr>
           <a:lstStyle/>
@@ -10026,7 +10015,6 @@
           <a:lstStyle/>
           <a:p>
             <a:pPr algn="ctr"/>
-            <a:endParaRPr/>
           </a:p>
         </p:txBody>
       </p:sp>
@@ -10047,7 +10035,7 @@
           <a:noFill/>
         </p:spPr>
         <p:txBody>
-          <a:bodyPr wrap="square" lIns="50800" tIns="12700" rIns="50800" bIns="12700" anchor="ctr">
+          <a:bodyPr wrap="square" anchor="ctr" lIns="50800" rIns="50800" tIns="12700" bIns="12700">
             <a:spAutoFit/>
           </a:bodyPr>
           <a:lstStyle/>
@@ -10057,7 +10045,15 @@
                 <a:spcPts val="200"/>
               </a:spcAft>
             </a:pPr>
-            <a:endParaRPr/>
+            <a:r>
+              <a:rPr sz="950" b="0">
+                <a:solidFill>
+                  <a:srgbClr val="0A0A0A"/>
+                </a:solidFill>
+                <a:latin typeface="맑은 고딕"/>
+              </a:rPr>
+              <a:t/>
+            </a:r>
           </a:p>
         </p:txBody>
       </p:sp>
@@ -10104,7 +10100,6 @@
           <a:lstStyle/>
           <a:p>
             <a:pPr algn="ctr"/>
-            <a:endParaRPr/>
           </a:p>
         </p:txBody>
       </p:sp>
@@ -10125,7 +10120,7 @@
           <a:noFill/>
         </p:spPr>
         <p:txBody>
-          <a:bodyPr wrap="square" lIns="50800" tIns="12700" rIns="50800" bIns="12700" anchor="ctr">
+          <a:bodyPr wrap="square" anchor="ctr" lIns="50800" rIns="50800" tIns="12700" bIns="12700">
             <a:spAutoFit/>
           </a:bodyPr>
           <a:lstStyle/>
@@ -10190,7 +10185,6 @@
           <a:lstStyle/>
           <a:p>
             <a:pPr algn="ctr"/>
-            <a:endParaRPr/>
           </a:p>
         </p:txBody>
       </p:sp>
@@ -10211,7 +10205,7 @@
           <a:noFill/>
         </p:spPr>
         <p:txBody>
-          <a:bodyPr wrap="square" lIns="50800" tIns="12700" rIns="50800" bIns="12700" anchor="ctr">
+          <a:bodyPr wrap="square" anchor="ctr" lIns="50800" rIns="50800" tIns="12700" bIns="12700">
             <a:spAutoFit/>
           </a:bodyPr>
           <a:lstStyle/>
@@ -10276,7 +10270,6 @@
           <a:lstStyle/>
           <a:p>
             <a:pPr algn="ctr"/>
-            <a:endParaRPr/>
           </a:p>
         </p:txBody>
       </p:sp>
@@ -10297,7 +10290,7 @@
           <a:noFill/>
         </p:spPr>
         <p:txBody>
-          <a:bodyPr wrap="square" lIns="50800" tIns="12700" rIns="50800" bIns="12700" anchor="ctr">
+          <a:bodyPr wrap="square" anchor="ctr" lIns="50800" rIns="50800" tIns="12700" bIns="12700">
             <a:spAutoFit/>
           </a:bodyPr>
           <a:lstStyle/>
@@ -10362,7 +10355,6 @@
           <a:lstStyle/>
           <a:p>
             <a:pPr algn="ctr"/>
-            <a:endParaRPr/>
           </a:p>
         </p:txBody>
       </p:sp>
@@ -10383,7 +10375,7 @@
           <a:noFill/>
         </p:spPr>
         <p:txBody>
-          <a:bodyPr wrap="square" lIns="50800" tIns="12700" rIns="50800" bIns="12700" anchor="ctr">
+          <a:bodyPr wrap="square" anchor="ctr" lIns="50800" rIns="50800" tIns="12700" bIns="12700">
             <a:spAutoFit/>
           </a:bodyPr>
           <a:lstStyle/>
@@ -10448,7 +10440,6 @@
           <a:lstStyle/>
           <a:p>
             <a:pPr algn="ctr"/>
-            <a:endParaRPr/>
           </a:p>
         </p:txBody>
       </p:sp>
@@ -10469,7 +10460,7 @@
           <a:noFill/>
         </p:spPr>
         <p:txBody>
-          <a:bodyPr wrap="square" lIns="50800" tIns="12700" rIns="50800" bIns="12700" anchor="ctr">
+          <a:bodyPr wrap="square" anchor="ctr" lIns="50800" rIns="50800" tIns="12700" bIns="12700">
             <a:spAutoFit/>
           </a:bodyPr>
           <a:lstStyle/>
@@ -10534,7 +10525,6 @@
           <a:lstStyle/>
           <a:p>
             <a:pPr algn="ctr"/>
-            <a:endParaRPr/>
           </a:p>
         </p:txBody>
       </p:sp>
@@ -10555,7 +10545,7 @@
           <a:noFill/>
         </p:spPr>
         <p:txBody>
-          <a:bodyPr wrap="square" lIns="50800" tIns="12700" rIns="50800" bIns="12700" anchor="ctr">
+          <a:bodyPr wrap="square" anchor="ctr" lIns="50800" rIns="50800" tIns="12700" bIns="12700">
             <a:spAutoFit/>
           </a:bodyPr>
           <a:lstStyle/>
@@ -10565,7 +10555,15 @@
                 <a:spcPts val="200"/>
               </a:spcAft>
             </a:pPr>
-            <a:endParaRPr/>
+            <a:r>
+              <a:rPr sz="950" b="0">
+                <a:solidFill>
+                  <a:srgbClr val="0A0A0A"/>
+                </a:solidFill>
+                <a:latin typeface="맑은 고딕"/>
+              </a:rPr>
+              <a:t/>
+            </a:r>
           </a:p>
         </p:txBody>
       </p:sp>
@@ -10612,7 +10610,6 @@
           <a:lstStyle/>
           <a:p>
             <a:pPr algn="ctr"/>
-            <a:endParaRPr/>
           </a:p>
         </p:txBody>
       </p:sp>
@@ -10633,7 +10630,7 @@
           <a:noFill/>
         </p:spPr>
         <p:txBody>
-          <a:bodyPr wrap="square" lIns="50800" tIns="12700" rIns="50800" bIns="12700" anchor="ctr">
+          <a:bodyPr wrap="square" anchor="ctr" lIns="50800" rIns="50800" tIns="12700" bIns="12700">
             <a:spAutoFit/>
           </a:bodyPr>
           <a:lstStyle/>
@@ -10698,7 +10695,6 @@
           <a:lstStyle/>
           <a:p>
             <a:pPr algn="ctr"/>
-            <a:endParaRPr/>
           </a:p>
         </p:txBody>
       </p:sp>
@@ -10719,7 +10715,7 @@
           <a:noFill/>
         </p:spPr>
         <p:txBody>
-          <a:bodyPr wrap="square" lIns="50800" tIns="12700" rIns="50800" bIns="12700" anchor="ctr">
+          <a:bodyPr wrap="square" anchor="ctr" lIns="50800" rIns="50800" tIns="12700" bIns="12700">
             <a:spAutoFit/>
           </a:bodyPr>
           <a:lstStyle/>
@@ -10784,7 +10780,6 @@
           <a:lstStyle/>
           <a:p>
             <a:pPr algn="ctr"/>
-            <a:endParaRPr/>
           </a:p>
         </p:txBody>
       </p:sp>
@@ -10805,7 +10800,7 @@
           <a:noFill/>
         </p:spPr>
         <p:txBody>
-          <a:bodyPr wrap="square" lIns="50800" tIns="12700" rIns="50800" bIns="12700" anchor="ctr">
+          <a:bodyPr wrap="square" anchor="ctr" lIns="50800" rIns="50800" tIns="12700" bIns="12700">
             <a:spAutoFit/>
           </a:bodyPr>
           <a:lstStyle/>
@@ -10870,7 +10865,6 @@
           <a:lstStyle/>
           <a:p>
             <a:pPr algn="ctr"/>
-            <a:endParaRPr/>
           </a:p>
         </p:txBody>
       </p:sp>
@@ -10891,7 +10885,7 @@
           <a:noFill/>
         </p:spPr>
         <p:txBody>
-          <a:bodyPr wrap="square" lIns="50800" tIns="12700" rIns="50800" bIns="12700" anchor="ctr">
+          <a:bodyPr wrap="square" anchor="ctr" lIns="50800" rIns="50800" tIns="12700" bIns="12700">
             <a:spAutoFit/>
           </a:bodyPr>
           <a:lstStyle/>
@@ -10956,7 +10950,6 @@
           <a:lstStyle/>
           <a:p>
             <a:pPr algn="ctr"/>
-            <a:endParaRPr/>
           </a:p>
         </p:txBody>
       </p:sp>
@@ -10977,7 +10970,7 @@
           <a:noFill/>
         </p:spPr>
         <p:txBody>
-          <a:bodyPr wrap="square" lIns="50800" tIns="12700" rIns="50800" bIns="12700" anchor="ctr">
+          <a:bodyPr wrap="square" anchor="ctr" lIns="50800" rIns="50800" tIns="12700" bIns="12700">
             <a:spAutoFit/>
           </a:bodyPr>
           <a:lstStyle/>
@@ -11042,7 +11035,6 @@
           <a:lstStyle/>
           <a:p>
             <a:pPr algn="ctr"/>
-            <a:endParaRPr/>
           </a:p>
         </p:txBody>
       </p:sp>
@@ -11063,7 +11055,7 @@
           <a:noFill/>
         </p:spPr>
         <p:txBody>
-          <a:bodyPr wrap="square" lIns="50800" tIns="12700" rIns="50800" bIns="12700" anchor="ctr">
+          <a:bodyPr wrap="square" anchor="ctr" lIns="50800" rIns="50800" tIns="12700" bIns="12700">
             <a:spAutoFit/>
           </a:bodyPr>
           <a:lstStyle/>
@@ -11073,7 +11065,15 @@
                 <a:spcPts val="200"/>
               </a:spcAft>
             </a:pPr>
-            <a:endParaRPr/>
+            <a:r>
+              <a:rPr sz="950" b="0">
+                <a:solidFill>
+                  <a:srgbClr val="0A0A0A"/>
+                </a:solidFill>
+                <a:latin typeface="맑은 고딕"/>
+              </a:rPr>
+              <a:t/>
+            </a:r>
           </a:p>
         </p:txBody>
       </p:sp>
@@ -11120,7 +11120,6 @@
           <a:lstStyle/>
           <a:p>
             <a:pPr algn="ctr"/>
-            <a:endParaRPr/>
           </a:p>
         </p:txBody>
       </p:sp>
@@ -11141,7 +11140,7 @@
           <a:noFill/>
         </p:spPr>
         <p:txBody>
-          <a:bodyPr wrap="square" lIns="50800" tIns="12700" rIns="50800" bIns="12700" anchor="ctr">
+          <a:bodyPr wrap="square" anchor="ctr" lIns="50800" rIns="50800" tIns="12700" bIns="12700">
             <a:spAutoFit/>
           </a:bodyPr>
           <a:lstStyle/>
@@ -11206,7 +11205,6 @@
           <a:lstStyle/>
           <a:p>
             <a:pPr algn="ctr"/>
-            <a:endParaRPr/>
           </a:p>
         </p:txBody>
       </p:sp>
@@ -11227,7 +11225,7 @@
           <a:noFill/>
         </p:spPr>
         <p:txBody>
-          <a:bodyPr wrap="square" lIns="50800" tIns="12700" rIns="50800" bIns="12700" anchor="ctr">
+          <a:bodyPr wrap="square" anchor="ctr" lIns="50800" rIns="50800" tIns="12700" bIns="12700">
             <a:spAutoFit/>
           </a:bodyPr>
           <a:lstStyle/>
@@ -11292,7 +11290,6 @@
           <a:lstStyle/>
           <a:p>
             <a:pPr algn="ctr"/>
-            <a:endParaRPr/>
           </a:p>
         </p:txBody>
       </p:sp>
@@ -11313,7 +11310,7 @@
           <a:noFill/>
         </p:spPr>
         <p:txBody>
-          <a:bodyPr wrap="square" lIns="50800" tIns="12700" rIns="50800" bIns="12700" anchor="ctr">
+          <a:bodyPr wrap="square" anchor="ctr" lIns="50800" rIns="50800" tIns="12700" bIns="12700">
             <a:spAutoFit/>
           </a:bodyPr>
           <a:lstStyle/>
@@ -11378,7 +11375,6 @@
           <a:lstStyle/>
           <a:p>
             <a:pPr algn="ctr"/>
-            <a:endParaRPr/>
           </a:p>
         </p:txBody>
       </p:sp>
@@ -11399,7 +11395,7 @@
           <a:noFill/>
         </p:spPr>
         <p:txBody>
-          <a:bodyPr wrap="square" lIns="50800" tIns="12700" rIns="50800" bIns="12700" anchor="ctr">
+          <a:bodyPr wrap="square" anchor="ctr" lIns="50800" rIns="50800" tIns="12700" bIns="12700">
             <a:spAutoFit/>
           </a:bodyPr>
           <a:lstStyle/>
@@ -11464,7 +11460,6 @@
           <a:lstStyle/>
           <a:p>
             <a:pPr algn="ctr"/>
-            <a:endParaRPr/>
           </a:p>
         </p:txBody>
       </p:sp>
@@ -11485,7 +11480,7 @@
           <a:noFill/>
         </p:spPr>
         <p:txBody>
-          <a:bodyPr wrap="square" lIns="50800" tIns="12700" rIns="50800" bIns="12700" anchor="ctr">
+          <a:bodyPr wrap="square" anchor="ctr" lIns="50800" rIns="50800" tIns="12700" bIns="12700">
             <a:spAutoFit/>
           </a:bodyPr>
           <a:lstStyle/>
@@ -11515,8 +11510,8 @@
         </p:nvSpPr>
         <p:spPr>
           <a:xfrm>
-            <a:off x="91440" y="4389121"/>
-            <a:ext cx="6172200" cy="941517"/>
+            <a:off x="274320" y="4443984"/>
+            <a:ext cx="11640312" cy="1417320"/>
           </a:xfrm>
           <a:prstGeom prst="roundRect">
             <a:avLst/>
@@ -11550,7 +11545,6 @@
           <a:lstStyle/>
           <a:p>
             <a:pPr algn="ctr"/>
-            <a:endParaRPr/>
           </a:p>
         </p:txBody>
       </p:sp>
@@ -11562,8 +11556,8 @@
         </p:nvSpPr>
         <p:spPr>
           <a:xfrm>
-            <a:off x="256032" y="4462273"/>
-            <a:ext cx="11311128" cy="225703"/>
+            <a:off x="438912" y="4517136"/>
+            <a:ext cx="11311128" cy="329184"/>
           </a:xfrm>
           <a:prstGeom prst="rect">
             <a:avLst/>
@@ -11571,7 +11565,7 @@
           <a:noFill/>
         </p:spPr>
         <p:txBody>
-          <a:bodyPr wrap="square" lIns="50800" tIns="12700" rIns="50800" bIns="12700" anchor="t">
+          <a:bodyPr wrap="square" anchor="t" lIns="50800" rIns="50800" tIns="12700" bIns="12700">
             <a:spAutoFit/>
           </a:bodyPr>
           <a:lstStyle/>
@@ -11601,8 +11595,8 @@
         </p:nvSpPr>
         <p:spPr>
           <a:xfrm>
-            <a:off x="274320" y="4760566"/>
-            <a:ext cx="6204204" cy="402674"/>
+            <a:off x="438912" y="4864608"/>
+            <a:ext cx="11311128" cy="923544"/>
           </a:xfrm>
           <a:prstGeom prst="rect">
             <a:avLst/>
@@ -11610,7 +11604,7 @@
           <a:noFill/>
         </p:spPr>
         <p:txBody>
-          <a:bodyPr wrap="square" lIns="50800" tIns="12700" rIns="50800" bIns="12700" anchor="t">
+          <a:bodyPr wrap="square" anchor="t" lIns="50800" rIns="50800" tIns="12700" bIns="12700">
             <a:spAutoFit/>
           </a:bodyPr>
           <a:lstStyle/>
@@ -11621,191 +11615,14 @@
               </a:spcAft>
             </a:pPr>
             <a:r>
-              <a:rPr sz="1100" b="0" dirty="0">
+              <a:rPr sz="1100" b="0">
                 <a:solidFill>
                   <a:srgbClr val="0A0A0A"/>
                 </a:solidFill>
                 <a:latin typeface="맑은 고딕"/>
               </a:rPr>
-              <a:t>• </a:t>
-            </a:r>
-            <a:r>
-              <a:rPr sz="1100" b="0" dirty="0" err="1">
-                <a:solidFill>
-                  <a:srgbClr val="0A0A0A"/>
-                </a:solidFill>
-                <a:latin typeface="맑은 고딕"/>
-              </a:rPr>
-              <a:t>그래프는</a:t>
-            </a:r>
-            <a:r>
-              <a:rPr sz="1100" b="0" dirty="0">
-                <a:solidFill>
-                  <a:srgbClr val="0A0A0A"/>
-                </a:solidFill>
-                <a:latin typeface="맑은 고딕"/>
-              </a:rPr>
-              <a:t> </a:t>
-            </a:r>
-            <a:r>
-              <a:rPr sz="1100" b="0" dirty="0" err="1">
-                <a:solidFill>
-                  <a:srgbClr val="0A0A0A"/>
-                </a:solidFill>
-                <a:latin typeface="맑은 고딕"/>
-              </a:rPr>
-              <a:t>F가</a:t>
-            </a:r>
-            <a:r>
-              <a:rPr sz="1100" b="0" dirty="0">
-                <a:solidFill>
-                  <a:srgbClr val="0A0A0A"/>
-                </a:solidFill>
-                <a:latin typeface="맑은 고딕"/>
-              </a:rPr>
-              <a:t> </a:t>
-            </a:r>
-            <a:r>
-              <a:rPr sz="1100" b="0" dirty="0" err="1">
-                <a:solidFill>
-                  <a:srgbClr val="0A0A0A"/>
-                </a:solidFill>
-                <a:latin typeface="맑은 고딕"/>
-              </a:rPr>
-              <a:t>아닌</a:t>
-            </a:r>
-            <a:r>
-              <a:rPr sz="1100" b="0" dirty="0">
-                <a:solidFill>
-                  <a:srgbClr val="0A0A0A"/>
-                </a:solidFill>
-                <a:latin typeface="맑은 고딕"/>
-              </a:rPr>
-              <a:t> </a:t>
-            </a:r>
-            <a:r>
-              <a:rPr sz="1100" b="1" dirty="0" err="1">
-                <a:solidFill>
-                  <a:srgbClr val="1E7E34"/>
-                </a:solidFill>
-                <a:latin typeface="맑은 고딕"/>
-              </a:rPr>
-              <a:t>p값이</a:t>
-            </a:r>
-            <a:r>
-              <a:rPr sz="1100" b="1" dirty="0">
-                <a:solidFill>
-                  <a:srgbClr val="1E7E34"/>
-                </a:solidFill>
-                <a:latin typeface="맑은 고딕"/>
-              </a:rPr>
-              <a:t> </a:t>
-            </a:r>
-            <a:r>
-              <a:rPr sz="1100" b="1" dirty="0" err="1">
-                <a:solidFill>
-                  <a:srgbClr val="1E7E34"/>
-                </a:solidFill>
-                <a:latin typeface="맑은 고딕"/>
-              </a:rPr>
-              <a:t>작을수록</a:t>
-            </a:r>
-            <a:r>
-              <a:rPr sz="1100" b="1" dirty="0">
-                <a:solidFill>
-                  <a:srgbClr val="1E7E34"/>
-                </a:solidFill>
-                <a:latin typeface="맑은 고딕"/>
-              </a:rPr>
-              <a:t> </a:t>
-            </a:r>
-            <a:r>
-              <a:rPr sz="1100" b="1" dirty="0" err="1">
-                <a:solidFill>
-                  <a:srgbClr val="1E7E34"/>
-                </a:solidFill>
-                <a:latin typeface="맑은 고딕"/>
-              </a:rPr>
-              <a:t>막대가</a:t>
-            </a:r>
-            <a:r>
-              <a:rPr sz="1100" b="1" dirty="0">
-                <a:solidFill>
-                  <a:srgbClr val="1E7E34"/>
-                </a:solidFill>
-                <a:latin typeface="맑은 고딕"/>
-              </a:rPr>
-              <a:t> </a:t>
-            </a:r>
-            <a:r>
-              <a:rPr sz="1100" b="1" dirty="0" err="1">
-                <a:solidFill>
-                  <a:srgbClr val="1E7E34"/>
-                </a:solidFill>
-                <a:latin typeface="맑은 고딕"/>
-              </a:rPr>
-              <a:t>높아지도록</a:t>
-            </a:r>
-            <a:r>
-              <a:rPr sz="1100" b="1" dirty="0">
-                <a:solidFill>
-                  <a:srgbClr val="1E7E34"/>
-                </a:solidFill>
-                <a:latin typeface="맑은 고딕"/>
-              </a:rPr>
-              <a:t> </a:t>
-            </a:r>
-            <a:r>
-              <a:rPr sz="1100" b="1" dirty="0" err="1">
-                <a:solidFill>
-                  <a:srgbClr val="1E7E34"/>
-                </a:solidFill>
-                <a:latin typeface="맑은 고딕"/>
-              </a:rPr>
-              <a:t>환산</a:t>
-            </a:r>
-            <a:r>
-              <a:rPr sz="1100" b="0" dirty="0" err="1">
-                <a:solidFill>
-                  <a:srgbClr val="0A0A0A"/>
-                </a:solidFill>
-                <a:latin typeface="맑은 고딕"/>
-              </a:rPr>
-              <a:t>해</a:t>
-            </a:r>
-            <a:r>
-              <a:rPr sz="1100" b="0" dirty="0">
-                <a:solidFill>
-                  <a:srgbClr val="0A0A0A"/>
-                </a:solidFill>
-                <a:latin typeface="맑은 고딕"/>
-              </a:rPr>
-              <a:t> </a:t>
-            </a:r>
-            <a:r>
-              <a:rPr sz="1100" b="0" dirty="0" err="1">
-                <a:solidFill>
-                  <a:srgbClr val="0A0A0A"/>
-                </a:solidFill>
-                <a:latin typeface="맑은 고딕"/>
-              </a:rPr>
-              <a:t>표시</a:t>
-            </a:r>
-            <a:r>
-              <a:rPr sz="1100" b="0" dirty="0">
-                <a:solidFill>
-                  <a:srgbClr val="0A0A0A"/>
-                </a:solidFill>
-                <a:latin typeface="맑은 고딕"/>
-              </a:rPr>
-              <a:t> </a:t>
-            </a:r>
-            <a:endParaRPr lang="en-US" sz="1100" b="0" dirty="0">
-              <a:solidFill>
-                <a:srgbClr val="0A0A0A"/>
-              </a:solidFill>
-              <a:latin typeface="맑은 고딕"/>
-            </a:endParaRPr>
+              <a:t>•  F값에는 '이 값 이상이면 유의'라는 고정된 기준이 없음 — 임계값이 표본 수(n=48)·래그(lag)마다 달라지기 때문</a:t>
+            </a:r>
           </a:p>
           <a:p>
             <a:pPr algn="l">
@@ -11814,88 +11631,102 @@
               </a:spcAft>
             </a:pPr>
             <a:r>
-              <a:rPr sz="1100" b="0" dirty="0">
+              <a:rPr sz="1100" b="0">
                 <a:solidFill>
                   <a:srgbClr val="0A0A0A"/>
                 </a:solidFill>
                 <a:latin typeface="맑은 고딕"/>
               </a:rPr>
-              <a:t>•  본 </a:t>
-            </a:r>
-            <a:r>
-              <a:rPr sz="1100" b="0" dirty="0" err="1">
-                <a:solidFill>
-                  <a:srgbClr val="0A0A0A"/>
+              <a:t>    (lag=1이면 F </a:t>
+            </a:r>
+            <a:r>
+              <a:rPr sz="1100" b="1">
+                <a:solidFill>
+                  <a:srgbClr val="2E6DA4"/>
                 </a:solidFill>
                 <a:latin typeface="맑은 고딕"/>
               </a:rPr>
-              <a:t>연구의</a:t>
-            </a:r>
-            <a:r>
-              <a:rPr sz="1100" b="0" dirty="0">
+              <a:t>≥ 약 4.06</a:t>
+            </a:r>
+            <a:r>
+              <a:rPr sz="1100" b="0">
                 <a:solidFill>
                   <a:srgbClr val="0A0A0A"/>
                 </a:solidFill>
                 <a:latin typeface="맑은 고딕"/>
               </a:rPr>
-              <a:t> </a:t>
-            </a:r>
-            <a:r>
-              <a:rPr sz="1100" b="0" dirty="0" err="1">
-                <a:solidFill>
-                  <a:srgbClr val="0A0A0A"/>
+              <a:t>, lag=2이면 F </a:t>
+            </a:r>
+            <a:r>
+              <a:rPr sz="1100" b="1">
+                <a:solidFill>
+                  <a:srgbClr val="2E6DA4"/>
                 </a:solidFill>
                 <a:latin typeface="맑은 고딕"/>
               </a:rPr>
-              <a:t>최종</a:t>
-            </a:r>
-            <a:r>
-              <a:rPr sz="1100" b="0" dirty="0">
+              <a:t>≥ 약 3.21</a:t>
+            </a:r>
+            <a:r>
+              <a:rPr sz="1100" b="0">
                 <a:solidFill>
                   <a:srgbClr val="0A0A0A"/>
                 </a:solidFill>
                 <a:latin typeface="맑은 고딕"/>
               </a:rPr>
-              <a:t> </a:t>
-            </a:r>
-            <a:r>
-              <a:rPr sz="1100" b="0" dirty="0" err="1">
+              <a:t>일 때 p&lt;0.05 — 같은 'p&lt;0.05'도 lag에 따라 F 값 자체는 다름)</a:t>
+            </a:r>
+          </a:p>
+          <a:p>
+            <a:pPr algn="l">
+              <a:spcAft>
+                <a:spcPts val="300"/>
+              </a:spcAft>
+            </a:pPr>
+            <a:r>
+              <a:rPr sz="1100" b="0">
                 <a:solidFill>
                   <a:srgbClr val="0A0A0A"/>
                 </a:solidFill>
                 <a:latin typeface="맑은 고딕"/>
               </a:rPr>
-              <a:t>판정</a:t>
-            </a:r>
-            <a:r>
-              <a:rPr sz="1100" b="0" dirty="0">
-                <a:solidFill>
-                  <a:srgbClr val="0A0A0A"/>
+              <a:t>•  그래서 그래프는 F가 아닌 </a:t>
+            </a:r>
+            <a:r>
+              <a:rPr sz="1100" b="1">
+                <a:solidFill>
+                  <a:srgbClr val="1E7E34"/>
                 </a:solidFill>
                 <a:latin typeface="맑은 고딕"/>
               </a:rPr>
-              <a:t> </a:t>
-            </a:r>
-            <a:r>
-              <a:rPr sz="1100" b="0" dirty="0" err="1">
+              <a:t>p값이 작을수록 막대가 높아지도록 환산</a:t>
+            </a:r>
+            <a:r>
+              <a:rPr sz="1100" b="0">
                 <a:solidFill>
                   <a:srgbClr val="0A0A0A"/>
                 </a:solidFill>
                 <a:latin typeface="맑은 고딕"/>
               </a:rPr>
-              <a:t>기준은</a:t>
-            </a:r>
-            <a:r>
-              <a:rPr sz="1100" b="0" dirty="0">
+              <a:t>해 표시 — 모든 채널에 동일한 기준선(p=0.05) 하나로 색상을 그대로 판단 가능</a:t>
+            </a:r>
+          </a:p>
+          <a:p>
+            <a:pPr algn="l">
+              <a:spcAft>
+                <a:spcPts val="300"/>
+              </a:spcAft>
+            </a:pPr>
+            <a:r>
+              <a:rPr sz="1100" b="0">
                 <a:solidFill>
                   <a:srgbClr val="0A0A0A"/>
                 </a:solidFill>
                 <a:latin typeface="맑은 고딕"/>
               </a:rPr>
-              <a:t> </a:t>
-            </a:r>
-            <a:r>
-              <a:rPr sz="1100" b="1" dirty="0">
+              <a:t>•  본 연구의 최종 판정 기준은 </a:t>
+            </a:r>
+            <a:r>
+              <a:rPr sz="1100" b="1">
                 <a:solidFill>
                   <a:srgbClr val="1E7E34"/>
                 </a:solidFill>
@@ -11904,121 +11735,29 @@
               <a:t>p &lt; 0.05</a:t>
             </a:r>
             <a:r>
-              <a:rPr sz="1100" b="0" dirty="0">
+              <a:rPr sz="1100" b="0">
                 <a:solidFill>
                   <a:srgbClr val="0A0A0A"/>
                 </a:solidFill>
                 <a:latin typeface="맑은 고딕"/>
               </a:rPr>
-              <a:t> </a:t>
-            </a:r>
-            <a:r>
-              <a:rPr sz="1100" b="0" dirty="0" err="1">
+              <a:t> 단 하나 — 기준선을 넘으면 '유의', 못 넘으면 '비유의'. F·lag 원값은 우측 표 참고</a:t>
+            </a:r>
+          </a:p>
+          <a:p>
+            <a:pPr algn="l">
+              <a:spcAft>
+                <a:spcPts val="300"/>
+              </a:spcAft>
+            </a:pPr>
+            <a:r>
+              <a:rPr sz="1100" b="0">
                 <a:solidFill>
                   <a:srgbClr val="0A0A0A"/>
                 </a:solidFill>
                 <a:latin typeface="맑은 고딕"/>
               </a:rPr>
-              <a:t>하나</a:t>
-            </a:r>
-            <a:r>
-              <a:rPr sz="1100" b="0" dirty="0">
-                <a:solidFill>
-                  <a:srgbClr val="0A0A0A"/>
-                </a:solidFill>
-                <a:latin typeface="맑은 고딕"/>
-              </a:rPr>
-              <a:t> — </a:t>
-            </a:r>
-            <a:r>
-              <a:rPr sz="1100" b="0" dirty="0" err="1">
-                <a:solidFill>
-                  <a:srgbClr val="0A0A0A"/>
-                </a:solidFill>
-                <a:latin typeface="맑은 고딕"/>
-              </a:rPr>
-              <a:t>기준선을</a:t>
-            </a:r>
-            <a:r>
-              <a:rPr sz="1100" b="0" dirty="0">
-                <a:solidFill>
-                  <a:srgbClr val="0A0A0A"/>
-                </a:solidFill>
-                <a:latin typeface="맑은 고딕"/>
-              </a:rPr>
-              <a:t> </a:t>
-            </a:r>
-            <a:r>
-              <a:rPr sz="1100" b="0" dirty="0" err="1">
-                <a:solidFill>
-                  <a:srgbClr val="0A0A0A"/>
-                </a:solidFill>
-                <a:latin typeface="맑은 고딕"/>
-              </a:rPr>
-              <a:t>넘으면</a:t>
-            </a:r>
-            <a:r>
-              <a:rPr sz="1100" b="0" dirty="0">
-                <a:solidFill>
-                  <a:srgbClr val="0A0A0A"/>
-                </a:solidFill>
-                <a:latin typeface="맑은 고딕"/>
-              </a:rPr>
-              <a:t> '</a:t>
-            </a:r>
-            <a:r>
-              <a:rPr sz="1100" b="0" dirty="0" err="1">
-                <a:solidFill>
-                  <a:srgbClr val="0A0A0A"/>
-                </a:solidFill>
-                <a:latin typeface="맑은 고딕"/>
-              </a:rPr>
-              <a:t>유의</a:t>
-            </a:r>
-            <a:r>
-              <a:rPr sz="1100" b="0" dirty="0">
-                <a:solidFill>
-                  <a:srgbClr val="0A0A0A"/>
-                </a:solidFill>
-                <a:latin typeface="맑은 고딕"/>
-              </a:rPr>
-              <a:t>', 못 </a:t>
-            </a:r>
-            <a:r>
-              <a:rPr sz="1100" b="0" dirty="0" err="1">
-                <a:solidFill>
-                  <a:srgbClr val="0A0A0A"/>
-                </a:solidFill>
-                <a:latin typeface="맑은 고딕"/>
-              </a:rPr>
-              <a:t>넘으면</a:t>
-            </a:r>
-            <a:r>
-              <a:rPr sz="1100" b="0" dirty="0">
-                <a:solidFill>
-                  <a:srgbClr val="0A0A0A"/>
-                </a:solidFill>
-                <a:latin typeface="맑은 고딕"/>
-              </a:rPr>
-              <a:t> '</a:t>
-            </a:r>
-            <a:r>
-              <a:rPr sz="1100" b="0" dirty="0" err="1">
-                <a:solidFill>
-                  <a:srgbClr val="0A0A0A"/>
-                </a:solidFill>
-                <a:latin typeface="맑은 고딕"/>
-              </a:rPr>
-              <a:t>비유의</a:t>
-            </a:r>
-            <a:r>
-              <a:rPr sz="1100" b="0" dirty="0">
-                <a:solidFill>
-                  <a:srgbClr val="0A0A0A"/>
-                </a:solidFill>
-                <a:latin typeface="맑은 고딕"/>
-              </a:rPr>
-              <a:t>'. </a:t>
+              <a:t>•  다중비교(BH) 보정을 적용하면 '유의' 4개 중 2개(스니커즈 CH3, 카드 CH1)만 남음 — 보수적 해석 시 참고</a:t>
             </a:r>
           </a:p>
         </p:txBody>
@@ -12031,7 +11770,7 @@
         </p:nvSpPr>
         <p:spPr>
           <a:xfrm>
-            <a:off x="6352795" y="4728080"/>
+            <a:off x="274320" y="5989320"/>
             <a:ext cx="5728716" cy="731520"/>
           </a:xfrm>
           <a:prstGeom prst="roundRect">
@@ -12064,7 +11803,6 @@
           <a:lstStyle/>
           <a:p>
             <a:pPr algn="ctr"/>
-            <a:endParaRPr/>
           </a:p>
         </p:txBody>
       </p:sp>
@@ -12076,7 +11814,7 @@
         </p:nvSpPr>
         <p:spPr>
           <a:xfrm>
-            <a:off x="6478524" y="4728080"/>
+            <a:off x="420623" y="5989320"/>
             <a:ext cx="5436108" cy="731520"/>
           </a:xfrm>
           <a:prstGeom prst="rect">
@@ -12085,7 +11823,7 @@
           <a:noFill/>
         </p:spPr>
         <p:txBody>
-          <a:bodyPr wrap="square" lIns="50800" tIns="12700" rIns="50800" bIns="12700" anchor="ctr">
+          <a:bodyPr wrap="square" anchor="ctr" lIns="50800" rIns="50800" tIns="12700" bIns="12700">
             <a:spAutoFit/>
           </a:bodyPr>
           <a:lstStyle/>
@@ -12096,22 +11834,13 @@
               </a:spcAft>
             </a:pPr>
             <a:r>
-              <a:rPr sz="1250" b="1" dirty="0" err="1">
+              <a:rPr sz="1250" b="1">
                 <a:solidFill>
                   <a:srgbClr val="FFFFFF"/>
                 </a:solidFill>
                 <a:latin typeface="맑은 고딕"/>
               </a:rPr>
-              <a:t>결론</a:t>
-            </a:r>
-            <a:r>
-              <a:rPr sz="1250" b="1" dirty="0">
-                <a:solidFill>
-                  <a:srgbClr val="FFFFFF"/>
-                </a:solidFill>
-                <a:latin typeface="맑은 고딕"/>
-              </a:rPr>
-              <a:t> RQ1  </a:t>
+              <a:t>결론 RQ1  </a:t>
             </a:r>
           </a:p>
           <a:p>
@@ -12121,166 +11850,13 @@
               </a:spcAft>
             </a:pPr>
             <a:r>
-              <a:rPr sz="1150" b="0" dirty="0" err="1">
+              <a:rPr sz="1150" b="0">
                 <a:solidFill>
                   <a:srgbClr val="FFFFFF"/>
                 </a:solidFill>
                 <a:latin typeface="맑은 고딕"/>
               </a:rPr>
-              <a:t>미디어가</a:t>
-            </a:r>
-            <a:r>
-              <a:rPr sz="1150" b="0" dirty="0">
-                <a:solidFill>
-                  <a:srgbClr val="FFFFFF"/>
-                </a:solidFill>
-                <a:latin typeface="맑은 고딕"/>
-              </a:rPr>
-              <a:t> </a:t>
-            </a:r>
-            <a:r>
-              <a:rPr sz="1150" b="0" dirty="0" err="1">
-                <a:solidFill>
-                  <a:srgbClr val="FFFFFF"/>
-                </a:solidFill>
-                <a:latin typeface="맑은 고딕"/>
-              </a:rPr>
-              <a:t>가격</a:t>
-            </a:r>
-            <a:r>
-              <a:rPr sz="1150" b="0" dirty="0">
-                <a:solidFill>
-                  <a:srgbClr val="FFFFFF"/>
-                </a:solidFill>
-                <a:latin typeface="맑은 고딕"/>
-              </a:rPr>
-              <a:t> </a:t>
-            </a:r>
-            <a:r>
-              <a:rPr sz="1150" b="0" dirty="0" err="1">
-                <a:solidFill>
-                  <a:srgbClr val="FFFFFF"/>
-                </a:solidFill>
-                <a:latin typeface="맑은 고딕"/>
-              </a:rPr>
-              <a:t>선행성</a:t>
-            </a:r>
-            <a:r>
-              <a:rPr sz="1150" b="0" dirty="0">
-                <a:solidFill>
-                  <a:srgbClr val="FFFFFF"/>
-                </a:solidFill>
-                <a:latin typeface="맑은 고딕"/>
-              </a:rPr>
-              <a:t> </a:t>
-            </a:r>
-            <a:r>
-              <a:rPr sz="1150" b="0" dirty="0" err="1">
-                <a:solidFill>
-                  <a:srgbClr val="FFFFFF"/>
-                </a:solidFill>
-                <a:latin typeface="맑은 고딕"/>
-              </a:rPr>
-              <a:t>부분</a:t>
-            </a:r>
-            <a:r>
-              <a:rPr sz="1150" b="0" dirty="0">
-                <a:solidFill>
-                  <a:srgbClr val="FFFFFF"/>
-                </a:solidFill>
-                <a:latin typeface="맑은 고딕"/>
-              </a:rPr>
-              <a:t> </a:t>
-            </a:r>
-            <a:r>
-              <a:rPr sz="1150" b="0" dirty="0" err="1">
-                <a:solidFill>
-                  <a:srgbClr val="FFFFFF"/>
-                </a:solidFill>
-                <a:latin typeface="맑은 고딕"/>
-              </a:rPr>
-              <a:t>지지</a:t>
-            </a:r>
-            <a:r>
-              <a:rPr sz="1150" b="0" dirty="0">
-                <a:solidFill>
-                  <a:srgbClr val="FFFFFF"/>
-                </a:solidFill>
-                <a:latin typeface="맑은 고딕"/>
-              </a:rPr>
-              <a:t> — </a:t>
-            </a:r>
-            <a:r>
-              <a:rPr sz="1150" b="0" dirty="0" err="1">
-                <a:solidFill>
-                  <a:srgbClr val="FFFFFF"/>
-                </a:solidFill>
-                <a:latin typeface="맑은 고딕"/>
-              </a:rPr>
-              <a:t>스니커즈</a:t>
-            </a:r>
-            <a:r>
-              <a:rPr sz="1150" b="0" dirty="0">
-                <a:solidFill>
-                  <a:srgbClr val="FFFFFF"/>
-                </a:solidFill>
-                <a:latin typeface="맑은 고딕"/>
-              </a:rPr>
-              <a:t> 3개(CH3·CH4·CH1)·</a:t>
-            </a:r>
-            <a:r>
-              <a:rPr sz="1150" b="0" dirty="0" err="1">
-                <a:solidFill>
-                  <a:srgbClr val="FFFFFF"/>
-                </a:solidFill>
-                <a:latin typeface="맑은 고딕"/>
-              </a:rPr>
-              <a:t>카드</a:t>
-            </a:r>
-            <a:r>
-              <a:rPr sz="1150" b="0" dirty="0">
-                <a:solidFill>
-                  <a:srgbClr val="FFFFFF"/>
-                </a:solidFill>
-                <a:latin typeface="맑은 고딕"/>
-              </a:rPr>
-              <a:t> 1개(CH1) </a:t>
-            </a:r>
-            <a:r>
-              <a:rPr sz="1150" b="0" dirty="0" err="1">
-                <a:solidFill>
-                  <a:srgbClr val="FFFFFF"/>
-                </a:solidFill>
-                <a:latin typeface="맑은 고딕"/>
-              </a:rPr>
-              <a:t>채널이</a:t>
-            </a:r>
-            <a:r>
-              <a:rPr sz="1150" b="0" dirty="0">
-                <a:solidFill>
-                  <a:srgbClr val="FFFFFF"/>
-                </a:solidFill>
-                <a:latin typeface="맑은 고딕"/>
-              </a:rPr>
-              <a:t> </a:t>
-            </a:r>
-            <a:r>
-              <a:rPr sz="1150" b="0" dirty="0" err="1">
-                <a:solidFill>
-                  <a:srgbClr val="FFFFFF"/>
-                </a:solidFill>
-                <a:latin typeface="맑은 고딕"/>
-              </a:rPr>
-              <a:t>유의</a:t>
-            </a:r>
-            <a:r>
-              <a:rPr sz="1150" b="0" dirty="0">
-                <a:solidFill>
-                  <a:srgbClr val="FFFFFF"/>
-                </a:solidFill>
-                <a:latin typeface="맑은 고딕"/>
-              </a:rPr>
-              <a:t>(p&lt;0.05)</a:t>
+              <a:t>미디어가 가격 선행성 부분 지지 — 스니커즈 3개(CH3·CH4·CH1)·카드 1개(CH1) 채널이 유의(p&lt;0.05)</a:t>
             </a:r>
           </a:p>
         </p:txBody>
@@ -12293,7 +11869,7 @@
         </p:nvSpPr>
         <p:spPr>
           <a:xfrm>
-            <a:off x="6332220" y="5623560"/>
+            <a:off x="6185916" y="5989320"/>
             <a:ext cx="5728716" cy="731520"/>
           </a:xfrm>
           <a:prstGeom prst="roundRect">
@@ -12326,7 +11902,6 @@
           <a:lstStyle/>
           <a:p>
             <a:pPr algn="ctr"/>
-            <a:endParaRPr/>
           </a:p>
         </p:txBody>
       </p:sp>
@@ -12338,7 +11913,7 @@
         </p:nvSpPr>
         <p:spPr>
           <a:xfrm>
-            <a:off x="6478524" y="5623560"/>
+            <a:off x="6332220" y="5989320"/>
             <a:ext cx="5436108" cy="731520"/>
           </a:xfrm>
           <a:prstGeom prst="rect">
@@ -12347,7 +11922,7 @@
           <a:noFill/>
         </p:spPr>
         <p:txBody>
-          <a:bodyPr wrap="square" lIns="50800" tIns="12700" rIns="50800" bIns="12700" anchor="ctr">
+          <a:bodyPr wrap="square" anchor="ctr" lIns="50800" rIns="50800" tIns="12700" bIns="12700">
             <a:spAutoFit/>
           </a:bodyPr>
           <a:lstStyle/>

</xml_diff>